<commit_message>
Cambios en la plantilla de diploma
</commit_message>
<xml_diff>
--- a/diploma/plantilla_diploma.pptx
+++ b/diploma/plantilla_diploma.pptx
@@ -1,25 +1,32 @@
 
 <file path=ppt/presentation.xml><?xml version="1.0" encoding="utf-8"?>
-<p:presentation xmlns:a="http://schemas.openxmlformats.org/drawingml/2006/main" xmlns:r="http://schemas.openxmlformats.org/officeDocument/2006/relationships" xmlns:p="http://schemas.openxmlformats.org/presentationml/2006/main" saveSubsetFonts="1" embedTrueTypeFonts="true">
+<p:presentation xmlns:a="http://schemas.openxmlformats.org/drawingml/2006/main" xmlns:r="http://schemas.openxmlformats.org/officeDocument/2006/relationships" xmlns:p="http://schemas.openxmlformats.org/presentationml/2006/main" embedTrueTypeFonts="1" saveSubsetFonts="1">
   <p:sldMasterIdLst>
     <p:sldMasterId id="2147483648" r:id="rId1"/>
   </p:sldMasterIdLst>
   <p:sldIdLst>
-    <p:sldId id="256" r:id="rId6"/>
+    <p:sldId id="256" r:id="rId2"/>
   </p:sldIdLst>
   <p:sldSz cx="10693400" cy="7556500"/>
   <p:notesSz cx="6858000" cy="9144000"/>
   <p:embeddedFontLst>
     <p:embeddedFont>
-      <p:font typeface="Times New Roman MT Italics" charset="1" panose="02030502070405090303"/>
+      <p:font typeface="Calibri" panose="020F0502020204030204" pitchFamily="34" charset="0"/>
+      <p:regular r:id="rId3"/>
+      <p:bold r:id="rId4"/>
+      <p:italic r:id="rId5"/>
+      <p:boldItalic r:id="rId6"/>
+    </p:embeddedFont>
+    <p:embeddedFont>
+      <p:font typeface="Times New Roman MT" panose="020B0604020202020204" charset="0"/>
       <p:regular r:id="rId7"/>
     </p:embeddedFont>
     <p:embeddedFont>
-      <p:font typeface="Times New Roman MT Bold" charset="1" panose="02030802070405020303"/>
+      <p:font typeface="Times New Roman MT Bold" panose="020B0604020202020204" charset="0"/>
       <p:regular r:id="rId8"/>
     </p:embeddedFont>
     <p:embeddedFont>
-      <p:font typeface="Times New Roman MT" charset="1" panose="02030502070405020303"/>
+      <p:font typeface="Times New Roman MT Italics" panose="020B0604020202020204" charset="0"/>
       <p:regular r:id="rId9"/>
     </p:embeddedFont>
   </p:embeddedFontLst>
@@ -118,6 +125,22 @@
       </a:defRPr>
     </a:lvl9pPr>
   </p:defaultTextStyle>
+  <p:extLst>
+    <p:ext uri="{EFAFB233-063F-42B5-8137-9DF3F51BA10A}">
+      <p15:sldGuideLst xmlns:p15="http://schemas.microsoft.com/office/powerpoint/2012/main">
+        <p15:guide id="1" orient="horz" pos="2160">
+          <p15:clr>
+            <a:srgbClr val="A4A3A4"/>
+          </p15:clr>
+        </p15:guide>
+        <p15:guide id="2" pos="2880">
+          <p15:clr>
+            <a:srgbClr val="A4A3A4"/>
+          </p15:clr>
+        </p15:guide>
+      </p15:sldGuideLst>
+    </p:ext>
+  </p:extLst>
 </p:presentation>
 </file>
 
@@ -159,10 +182,9 @@
           <a:lstStyle/>
           <a:p>
             <a:r>
-              <a:rPr lang="en-US" smtClean="0"/>
+              <a:rPr lang="en-US"/>
               <a:t>Click to edit Master title style</a:t>
             </a:r>
-            <a:endParaRPr lang="en-US"/>
           </a:p>
         </p:txBody>
       </p:sp>
@@ -278,10 +300,9 @@
           </a:lstStyle>
           <a:p>
             <a:r>
-              <a:rPr lang="en-US" smtClean="0"/>
+              <a:rPr lang="en-US"/>
               <a:t>Click to edit Master subtitle style</a:t>
             </a:r>
-            <a:endParaRPr lang="en-US"/>
           </a:p>
         </p:txBody>
       </p:sp>
@@ -303,7 +324,7 @@
             <a:fld id="{1D8BD707-D9CF-40AE-B4C6-C98DA3205C09}" type="datetimeFigureOut">
               <a:rPr lang="en-US" smtClean="0"/>
               <a:pPr/>
-              <a:t>8/1/2011</a:t>
+              <a:t>9/29/2026</a:t>
             </a:fld>
             <a:endParaRPr lang="en-US"/>
           </a:p>
@@ -346,7 +367,7 @@
             <a:fld id="{B6F15528-21DE-4FAA-801E-634DDDAF4B2B}" type="slidenum">
               <a:rPr lang="en-US" smtClean="0"/>
               <a:pPr/>
-              <a:t>‹#›</a:t>
+              <a:t>‹Nº›</a:t>
             </a:fld>
             <a:endParaRPr lang="en-US"/>
           </a:p>
@@ -393,10 +414,9 @@
           <a:lstStyle/>
           <a:p>
             <a:r>
-              <a:rPr lang="en-US" smtClean="0"/>
+              <a:rPr lang="en-US"/>
               <a:t>Click to edit Master title style</a:t>
             </a:r>
-            <a:endParaRPr lang="en-US"/>
           </a:p>
         </p:txBody>
       </p:sp>
@@ -417,38 +437,37 @@
           <a:p>
             <a:pPr lvl="0"/>
             <a:r>
-              <a:rPr lang="en-US" smtClean="0"/>
+              <a:rPr lang="en-US"/>
               <a:t>Click to edit Master text styles</a:t>
             </a:r>
           </a:p>
           <a:p>
             <a:pPr lvl="1"/>
             <a:r>
-              <a:rPr lang="en-US" smtClean="0"/>
+              <a:rPr lang="en-US"/>
               <a:t>Second level</a:t>
             </a:r>
           </a:p>
           <a:p>
             <a:pPr lvl="2"/>
             <a:r>
-              <a:rPr lang="en-US" smtClean="0"/>
+              <a:rPr lang="en-US"/>
               <a:t>Third level</a:t>
             </a:r>
           </a:p>
           <a:p>
             <a:pPr lvl="3"/>
             <a:r>
-              <a:rPr lang="en-US" smtClean="0"/>
+              <a:rPr lang="en-US"/>
               <a:t>Fourth level</a:t>
             </a:r>
           </a:p>
           <a:p>
             <a:pPr lvl="4"/>
             <a:r>
-              <a:rPr lang="en-US" smtClean="0"/>
+              <a:rPr lang="en-US"/>
               <a:t>Fifth level</a:t>
             </a:r>
-            <a:endParaRPr lang="en-US"/>
           </a:p>
         </p:txBody>
       </p:sp>
@@ -470,7 +489,7 @@
             <a:fld id="{1D8BD707-D9CF-40AE-B4C6-C98DA3205C09}" type="datetimeFigureOut">
               <a:rPr lang="en-US" smtClean="0"/>
               <a:pPr/>
-              <a:t>8/1/2011</a:t>
+              <a:t>9/29/2026</a:t>
             </a:fld>
             <a:endParaRPr lang="en-US"/>
           </a:p>
@@ -513,7 +532,7 @@
             <a:fld id="{B6F15528-21DE-4FAA-801E-634DDDAF4B2B}" type="slidenum">
               <a:rPr lang="en-US" smtClean="0"/>
               <a:pPr/>
-              <a:t>‹#›</a:t>
+              <a:t>‹Nº›</a:t>
             </a:fld>
             <a:endParaRPr lang="en-US"/>
           </a:p>
@@ -565,10 +584,9 @@
           <a:lstStyle/>
           <a:p>
             <a:r>
-              <a:rPr lang="en-US" smtClean="0"/>
+              <a:rPr lang="en-US"/>
               <a:t>Click to edit Master title style</a:t>
             </a:r>
-            <a:endParaRPr lang="en-US"/>
           </a:p>
         </p:txBody>
       </p:sp>
@@ -594,38 +612,37 @@
           <a:p>
             <a:pPr lvl="0"/>
             <a:r>
-              <a:rPr lang="en-US" smtClean="0"/>
+              <a:rPr lang="en-US"/>
               <a:t>Click to edit Master text styles</a:t>
             </a:r>
           </a:p>
           <a:p>
             <a:pPr lvl="1"/>
             <a:r>
-              <a:rPr lang="en-US" smtClean="0"/>
+              <a:rPr lang="en-US"/>
               <a:t>Second level</a:t>
             </a:r>
           </a:p>
           <a:p>
             <a:pPr lvl="2"/>
             <a:r>
-              <a:rPr lang="en-US" smtClean="0"/>
+              <a:rPr lang="en-US"/>
               <a:t>Third level</a:t>
             </a:r>
           </a:p>
           <a:p>
             <a:pPr lvl="3"/>
             <a:r>
-              <a:rPr lang="en-US" smtClean="0"/>
+              <a:rPr lang="en-US"/>
               <a:t>Fourth level</a:t>
             </a:r>
           </a:p>
           <a:p>
             <a:pPr lvl="4"/>
             <a:r>
-              <a:rPr lang="en-US" smtClean="0"/>
+              <a:rPr lang="en-US"/>
               <a:t>Fifth level</a:t>
             </a:r>
-            <a:endParaRPr lang="en-US"/>
           </a:p>
         </p:txBody>
       </p:sp>
@@ -647,7 +664,7 @@
             <a:fld id="{1D8BD707-D9CF-40AE-B4C6-C98DA3205C09}" type="datetimeFigureOut">
               <a:rPr lang="en-US" smtClean="0"/>
               <a:pPr/>
-              <a:t>8/1/2011</a:t>
+              <a:t>9/29/2026</a:t>
             </a:fld>
             <a:endParaRPr lang="en-US"/>
           </a:p>
@@ -690,7 +707,7 @@
             <a:fld id="{B6F15528-21DE-4FAA-801E-634DDDAF4B2B}" type="slidenum">
               <a:rPr lang="en-US" smtClean="0"/>
               <a:pPr/>
-              <a:t>‹#›</a:t>
+              <a:t>‹Nº›</a:t>
             </a:fld>
             <a:endParaRPr lang="en-US"/>
           </a:p>
@@ -737,10 +754,9 @@
           <a:lstStyle/>
           <a:p>
             <a:r>
-              <a:rPr lang="en-US" smtClean="0"/>
+              <a:rPr lang="en-US"/>
               <a:t>Click to edit Master title style</a:t>
             </a:r>
-            <a:endParaRPr lang="en-US"/>
           </a:p>
         </p:txBody>
       </p:sp>
@@ -761,38 +777,37 @@
           <a:p>
             <a:pPr lvl="0"/>
             <a:r>
-              <a:rPr lang="en-US" smtClean="0"/>
+              <a:rPr lang="en-US"/>
               <a:t>Click to edit Master text styles</a:t>
             </a:r>
           </a:p>
           <a:p>
             <a:pPr lvl="1"/>
             <a:r>
-              <a:rPr lang="en-US" smtClean="0"/>
+              <a:rPr lang="en-US"/>
               <a:t>Second level</a:t>
             </a:r>
           </a:p>
           <a:p>
             <a:pPr lvl="2"/>
             <a:r>
-              <a:rPr lang="en-US" smtClean="0"/>
+              <a:rPr lang="en-US"/>
               <a:t>Third level</a:t>
             </a:r>
           </a:p>
           <a:p>
             <a:pPr lvl="3"/>
             <a:r>
-              <a:rPr lang="en-US" smtClean="0"/>
+              <a:rPr lang="en-US"/>
               <a:t>Fourth level</a:t>
             </a:r>
           </a:p>
           <a:p>
             <a:pPr lvl="4"/>
             <a:r>
-              <a:rPr lang="en-US" smtClean="0"/>
+              <a:rPr lang="en-US"/>
               <a:t>Fifth level</a:t>
             </a:r>
-            <a:endParaRPr lang="en-US"/>
           </a:p>
         </p:txBody>
       </p:sp>
@@ -814,7 +829,7 @@
             <a:fld id="{1D8BD707-D9CF-40AE-B4C6-C98DA3205C09}" type="datetimeFigureOut">
               <a:rPr lang="en-US" smtClean="0"/>
               <a:pPr/>
-              <a:t>8/1/2011</a:t>
+              <a:t>9/29/2026</a:t>
             </a:fld>
             <a:endParaRPr lang="en-US"/>
           </a:p>
@@ -857,7 +872,7 @@
             <a:fld id="{B6F15528-21DE-4FAA-801E-634DDDAF4B2B}" type="slidenum">
               <a:rPr lang="en-US" smtClean="0"/>
               <a:pPr/>
-              <a:t>‹#›</a:t>
+              <a:t>‹Nº›</a:t>
             </a:fld>
             <a:endParaRPr lang="en-US"/>
           </a:p>
@@ -913,10 +928,9 @@
           </a:lstStyle>
           <a:p>
             <a:r>
-              <a:rPr lang="en-US" smtClean="0"/>
+              <a:rPr lang="en-US"/>
               <a:t>Click to edit Master title style</a:t>
             </a:r>
-            <a:endParaRPr lang="en-US"/>
           </a:p>
         </p:txBody>
       </p:sp>
@@ -1033,7 +1047,7 @@
           <a:p>
             <a:pPr lvl="0"/>
             <a:r>
-              <a:rPr lang="en-US" smtClean="0"/>
+              <a:rPr lang="en-US"/>
               <a:t>Click to edit Master text styles</a:t>
             </a:r>
           </a:p>
@@ -1057,7 +1071,7 @@
             <a:fld id="{1D8BD707-D9CF-40AE-B4C6-C98DA3205C09}" type="datetimeFigureOut">
               <a:rPr lang="en-US" smtClean="0"/>
               <a:pPr/>
-              <a:t>8/1/2011</a:t>
+              <a:t>9/29/2026</a:t>
             </a:fld>
             <a:endParaRPr lang="en-US"/>
           </a:p>
@@ -1100,7 +1114,7 @@
             <a:fld id="{B6F15528-21DE-4FAA-801E-634DDDAF4B2B}" type="slidenum">
               <a:rPr lang="en-US" smtClean="0"/>
               <a:pPr/>
-              <a:t>‹#›</a:t>
+              <a:t>‹Nº›</a:t>
             </a:fld>
             <a:endParaRPr lang="en-US"/>
           </a:p>
@@ -1147,10 +1161,9 @@
           <a:lstStyle/>
           <a:p>
             <a:r>
-              <a:rPr lang="en-US" smtClean="0"/>
+              <a:rPr lang="en-US"/>
               <a:t>Click to edit Master title style</a:t>
             </a:r>
-            <a:endParaRPr lang="en-US"/>
           </a:p>
         </p:txBody>
       </p:sp>
@@ -1204,38 +1217,37 @@
           <a:p>
             <a:pPr lvl="0"/>
             <a:r>
-              <a:rPr lang="en-US" smtClean="0"/>
+              <a:rPr lang="en-US"/>
               <a:t>Click to edit Master text styles</a:t>
             </a:r>
           </a:p>
           <a:p>
             <a:pPr lvl="1"/>
             <a:r>
-              <a:rPr lang="en-US" smtClean="0"/>
+              <a:rPr lang="en-US"/>
               <a:t>Second level</a:t>
             </a:r>
           </a:p>
           <a:p>
             <a:pPr lvl="2"/>
             <a:r>
-              <a:rPr lang="en-US" smtClean="0"/>
+              <a:rPr lang="en-US"/>
               <a:t>Third level</a:t>
             </a:r>
           </a:p>
           <a:p>
             <a:pPr lvl="3"/>
             <a:r>
-              <a:rPr lang="en-US" smtClean="0"/>
+              <a:rPr lang="en-US"/>
               <a:t>Fourth level</a:t>
             </a:r>
           </a:p>
           <a:p>
             <a:pPr lvl="4"/>
             <a:r>
-              <a:rPr lang="en-US" smtClean="0"/>
+              <a:rPr lang="en-US"/>
               <a:t>Fifth level</a:t>
             </a:r>
-            <a:endParaRPr lang="en-US"/>
           </a:p>
         </p:txBody>
       </p:sp>
@@ -1289,38 +1301,37 @@
           <a:p>
             <a:pPr lvl="0"/>
             <a:r>
-              <a:rPr lang="en-US" smtClean="0"/>
+              <a:rPr lang="en-US"/>
               <a:t>Click to edit Master text styles</a:t>
             </a:r>
           </a:p>
           <a:p>
             <a:pPr lvl="1"/>
             <a:r>
-              <a:rPr lang="en-US" smtClean="0"/>
+              <a:rPr lang="en-US"/>
               <a:t>Second level</a:t>
             </a:r>
           </a:p>
           <a:p>
             <a:pPr lvl="2"/>
             <a:r>
-              <a:rPr lang="en-US" smtClean="0"/>
+              <a:rPr lang="en-US"/>
               <a:t>Third level</a:t>
             </a:r>
           </a:p>
           <a:p>
             <a:pPr lvl="3"/>
             <a:r>
-              <a:rPr lang="en-US" smtClean="0"/>
+              <a:rPr lang="en-US"/>
               <a:t>Fourth level</a:t>
             </a:r>
           </a:p>
           <a:p>
             <a:pPr lvl="4"/>
             <a:r>
-              <a:rPr lang="en-US" smtClean="0"/>
+              <a:rPr lang="en-US"/>
               <a:t>Fifth level</a:t>
             </a:r>
-            <a:endParaRPr lang="en-US"/>
           </a:p>
         </p:txBody>
       </p:sp>
@@ -1342,7 +1353,7 @@
             <a:fld id="{1D8BD707-D9CF-40AE-B4C6-C98DA3205C09}" type="datetimeFigureOut">
               <a:rPr lang="en-US" smtClean="0"/>
               <a:pPr/>
-              <a:t>8/1/2011</a:t>
+              <a:t>9/29/2026</a:t>
             </a:fld>
             <a:endParaRPr lang="en-US"/>
           </a:p>
@@ -1385,7 +1396,7 @@
             <a:fld id="{B6F15528-21DE-4FAA-801E-634DDDAF4B2B}" type="slidenum">
               <a:rPr lang="en-US" smtClean="0"/>
               <a:pPr/>
-              <a:t>‹#›</a:t>
+              <a:t>‹Nº›</a:t>
             </a:fld>
             <a:endParaRPr lang="en-US"/>
           </a:p>
@@ -1436,10 +1447,9 @@
           </a:lstStyle>
           <a:p>
             <a:r>
-              <a:rPr lang="en-US" smtClean="0"/>
+              <a:rPr lang="en-US"/>
               <a:t>Click to edit Master title style</a:t>
             </a:r>
-            <a:endParaRPr lang="en-US"/>
           </a:p>
         </p:txBody>
       </p:sp>
@@ -1502,7 +1512,7 @@
           <a:p>
             <a:pPr lvl="0"/>
             <a:r>
-              <a:rPr lang="en-US" smtClean="0"/>
+              <a:rPr lang="en-US"/>
               <a:t>Click to edit Master text styles</a:t>
             </a:r>
           </a:p>
@@ -1558,38 +1568,37 @@
           <a:p>
             <a:pPr lvl="0"/>
             <a:r>
-              <a:rPr lang="en-US" smtClean="0"/>
+              <a:rPr lang="en-US"/>
               <a:t>Click to edit Master text styles</a:t>
             </a:r>
           </a:p>
           <a:p>
             <a:pPr lvl="1"/>
             <a:r>
-              <a:rPr lang="en-US" smtClean="0"/>
+              <a:rPr lang="en-US"/>
               <a:t>Second level</a:t>
             </a:r>
           </a:p>
           <a:p>
             <a:pPr lvl="2"/>
             <a:r>
-              <a:rPr lang="en-US" smtClean="0"/>
+              <a:rPr lang="en-US"/>
               <a:t>Third level</a:t>
             </a:r>
           </a:p>
           <a:p>
             <a:pPr lvl="3"/>
             <a:r>
-              <a:rPr lang="en-US" smtClean="0"/>
+              <a:rPr lang="en-US"/>
               <a:t>Fourth level</a:t>
             </a:r>
           </a:p>
           <a:p>
             <a:pPr lvl="4"/>
             <a:r>
-              <a:rPr lang="en-US" smtClean="0"/>
+              <a:rPr lang="en-US"/>
               <a:t>Fifth level</a:t>
             </a:r>
-            <a:endParaRPr lang="en-US"/>
           </a:p>
         </p:txBody>
       </p:sp>
@@ -1652,7 +1661,7 @@
           <a:p>
             <a:pPr lvl="0"/>
             <a:r>
-              <a:rPr lang="en-US" smtClean="0"/>
+              <a:rPr lang="en-US"/>
               <a:t>Click to edit Master text styles</a:t>
             </a:r>
           </a:p>
@@ -1708,38 +1717,37 @@
           <a:p>
             <a:pPr lvl="0"/>
             <a:r>
-              <a:rPr lang="en-US" smtClean="0"/>
+              <a:rPr lang="en-US"/>
               <a:t>Click to edit Master text styles</a:t>
             </a:r>
           </a:p>
           <a:p>
             <a:pPr lvl="1"/>
             <a:r>
-              <a:rPr lang="en-US" smtClean="0"/>
+              <a:rPr lang="en-US"/>
               <a:t>Second level</a:t>
             </a:r>
           </a:p>
           <a:p>
             <a:pPr lvl="2"/>
             <a:r>
-              <a:rPr lang="en-US" smtClean="0"/>
+              <a:rPr lang="en-US"/>
               <a:t>Third level</a:t>
             </a:r>
           </a:p>
           <a:p>
             <a:pPr lvl="3"/>
             <a:r>
-              <a:rPr lang="en-US" smtClean="0"/>
+              <a:rPr lang="en-US"/>
               <a:t>Fourth level</a:t>
             </a:r>
           </a:p>
           <a:p>
             <a:pPr lvl="4"/>
             <a:r>
-              <a:rPr lang="en-US" smtClean="0"/>
+              <a:rPr lang="en-US"/>
               <a:t>Fifth level</a:t>
             </a:r>
-            <a:endParaRPr lang="en-US"/>
           </a:p>
         </p:txBody>
       </p:sp>
@@ -1761,7 +1769,7 @@
             <a:fld id="{1D8BD707-D9CF-40AE-B4C6-C98DA3205C09}" type="datetimeFigureOut">
               <a:rPr lang="en-US" smtClean="0"/>
               <a:pPr/>
-              <a:t>8/1/2011</a:t>
+              <a:t>9/29/2026</a:t>
             </a:fld>
             <a:endParaRPr lang="en-US"/>
           </a:p>
@@ -1804,7 +1812,7 @@
             <a:fld id="{B6F15528-21DE-4FAA-801E-634DDDAF4B2B}" type="slidenum">
               <a:rPr lang="en-US" smtClean="0"/>
               <a:pPr/>
-              <a:t>‹#›</a:t>
+              <a:t>‹Nº›</a:t>
             </a:fld>
             <a:endParaRPr lang="en-US"/>
           </a:p>
@@ -1851,10 +1859,9 @@
           <a:lstStyle/>
           <a:p>
             <a:r>
-              <a:rPr lang="en-US" smtClean="0"/>
+              <a:rPr lang="en-US"/>
               <a:t>Click to edit Master title style</a:t>
             </a:r>
-            <a:endParaRPr lang="en-US"/>
           </a:p>
         </p:txBody>
       </p:sp>
@@ -1876,7 +1883,7 @@
             <a:fld id="{1D8BD707-D9CF-40AE-B4C6-C98DA3205C09}" type="datetimeFigureOut">
               <a:rPr lang="en-US" smtClean="0"/>
               <a:pPr/>
-              <a:t>8/1/2011</a:t>
+              <a:t>9/29/2026</a:t>
             </a:fld>
             <a:endParaRPr lang="en-US"/>
           </a:p>
@@ -1919,7 +1926,7 @@
             <a:fld id="{B6F15528-21DE-4FAA-801E-634DDDAF4B2B}" type="slidenum">
               <a:rPr lang="en-US" smtClean="0"/>
               <a:pPr/>
-              <a:t>‹#›</a:t>
+              <a:t>‹Nº›</a:t>
             </a:fld>
             <a:endParaRPr lang="en-US"/>
           </a:p>
@@ -1968,7 +1975,7 @@
             <a:fld id="{1D8BD707-D9CF-40AE-B4C6-C98DA3205C09}" type="datetimeFigureOut">
               <a:rPr lang="en-US" smtClean="0"/>
               <a:pPr/>
-              <a:t>8/1/2011</a:t>
+              <a:t>9/29/2026</a:t>
             </a:fld>
             <a:endParaRPr lang="en-US"/>
           </a:p>
@@ -2011,7 +2018,7 @@
             <a:fld id="{B6F15528-21DE-4FAA-801E-634DDDAF4B2B}" type="slidenum">
               <a:rPr lang="en-US" smtClean="0"/>
               <a:pPr/>
-              <a:t>‹#›</a:t>
+              <a:t>‹Nº›</a:t>
             </a:fld>
             <a:endParaRPr lang="en-US"/>
           </a:p>
@@ -2067,10 +2074,9 @@
           </a:lstStyle>
           <a:p>
             <a:r>
-              <a:rPr lang="en-US" smtClean="0"/>
+              <a:rPr lang="en-US"/>
               <a:t>Click to edit Master title style</a:t>
             </a:r>
-            <a:endParaRPr lang="en-US"/>
           </a:p>
         </p:txBody>
       </p:sp>
@@ -2124,38 +2130,37 @@
           <a:p>
             <a:pPr lvl="0"/>
             <a:r>
-              <a:rPr lang="en-US" smtClean="0"/>
+              <a:rPr lang="en-US"/>
               <a:t>Click to edit Master text styles</a:t>
             </a:r>
           </a:p>
           <a:p>
             <a:pPr lvl="1"/>
             <a:r>
-              <a:rPr lang="en-US" smtClean="0"/>
+              <a:rPr lang="en-US"/>
               <a:t>Second level</a:t>
             </a:r>
           </a:p>
           <a:p>
             <a:pPr lvl="2"/>
             <a:r>
-              <a:rPr lang="en-US" smtClean="0"/>
+              <a:rPr lang="en-US"/>
               <a:t>Third level</a:t>
             </a:r>
           </a:p>
           <a:p>
             <a:pPr lvl="3"/>
             <a:r>
-              <a:rPr lang="en-US" smtClean="0"/>
+              <a:rPr lang="en-US"/>
               <a:t>Fourth level</a:t>
             </a:r>
           </a:p>
           <a:p>
             <a:pPr lvl="4"/>
             <a:r>
-              <a:rPr lang="en-US" smtClean="0"/>
+              <a:rPr lang="en-US"/>
               <a:t>Fifth level</a:t>
             </a:r>
-            <a:endParaRPr lang="en-US"/>
           </a:p>
         </p:txBody>
       </p:sp>
@@ -2218,7 +2223,7 @@
           <a:p>
             <a:pPr lvl="0"/>
             <a:r>
-              <a:rPr lang="en-US" smtClean="0"/>
+              <a:rPr lang="en-US"/>
               <a:t>Click to edit Master text styles</a:t>
             </a:r>
           </a:p>
@@ -2242,7 +2247,7 @@
             <a:fld id="{1D8BD707-D9CF-40AE-B4C6-C98DA3205C09}" type="datetimeFigureOut">
               <a:rPr lang="en-US" smtClean="0"/>
               <a:pPr/>
-              <a:t>8/1/2011</a:t>
+              <a:t>9/29/2026</a:t>
             </a:fld>
             <a:endParaRPr lang="en-US"/>
           </a:p>
@@ -2285,7 +2290,7 @@
             <a:fld id="{B6F15528-21DE-4FAA-801E-634DDDAF4B2B}" type="slidenum">
               <a:rPr lang="en-US" smtClean="0"/>
               <a:pPr/>
-              <a:t>‹#›</a:t>
+              <a:t>‹Nº›</a:t>
             </a:fld>
             <a:endParaRPr lang="en-US"/>
           </a:p>
@@ -2341,10 +2346,9 @@
           </a:lstStyle>
           <a:p>
             <a:r>
-              <a:rPr lang="en-US" smtClean="0"/>
+              <a:rPr lang="en-US"/>
               <a:t>Click to edit Master title style</a:t>
             </a:r>
-            <a:endParaRPr lang="en-US"/>
           </a:p>
         </p:txBody>
       </p:sp>
@@ -2468,7 +2472,7 @@
           <a:p>
             <a:pPr lvl="0"/>
             <a:r>
-              <a:rPr lang="en-US" smtClean="0"/>
+              <a:rPr lang="en-US"/>
               <a:t>Click to edit Master text styles</a:t>
             </a:r>
           </a:p>
@@ -2492,7 +2496,7 @@
             <a:fld id="{1D8BD707-D9CF-40AE-B4C6-C98DA3205C09}" type="datetimeFigureOut">
               <a:rPr lang="en-US" smtClean="0"/>
               <a:pPr/>
-              <a:t>8/1/2011</a:t>
+              <a:t>9/29/2026</a:t>
             </a:fld>
             <a:endParaRPr lang="en-US"/>
           </a:p>
@@ -2535,7 +2539,7 @@
             <a:fld id="{B6F15528-21DE-4FAA-801E-634DDDAF4B2B}" type="slidenum">
               <a:rPr lang="en-US" smtClean="0"/>
               <a:pPr/>
-              <a:t>‹#›</a:t>
+              <a:t>‹Nº›</a:t>
             </a:fld>
             <a:endParaRPr lang="en-US"/>
           </a:p>
@@ -2597,10 +2601,9 @@
           <a:lstStyle/>
           <a:p>
             <a:r>
-              <a:rPr lang="en-US" smtClean="0"/>
+              <a:rPr lang="en-US"/>
               <a:t>Click to edit Master title style</a:t>
             </a:r>
-            <a:endParaRPr lang="en-US"/>
           </a:p>
         </p:txBody>
       </p:sp>
@@ -2631,38 +2634,37 @@
           <a:p>
             <a:pPr lvl="0"/>
             <a:r>
-              <a:rPr lang="en-US" smtClean="0"/>
+              <a:rPr lang="en-US"/>
               <a:t>Click to edit Master text styles</a:t>
             </a:r>
           </a:p>
           <a:p>
             <a:pPr lvl="1"/>
             <a:r>
-              <a:rPr lang="en-US" smtClean="0"/>
+              <a:rPr lang="en-US"/>
               <a:t>Second level</a:t>
             </a:r>
           </a:p>
           <a:p>
             <a:pPr lvl="2"/>
             <a:r>
-              <a:rPr lang="en-US" smtClean="0"/>
+              <a:rPr lang="en-US"/>
               <a:t>Third level</a:t>
             </a:r>
           </a:p>
           <a:p>
             <a:pPr lvl="3"/>
             <a:r>
-              <a:rPr lang="en-US" smtClean="0"/>
+              <a:rPr lang="en-US"/>
               <a:t>Fourth level</a:t>
             </a:r>
           </a:p>
           <a:p>
             <a:pPr lvl="4"/>
             <a:r>
-              <a:rPr lang="en-US" smtClean="0"/>
+              <a:rPr lang="en-US"/>
               <a:t>Fifth level</a:t>
             </a:r>
-            <a:endParaRPr lang="en-US"/>
           </a:p>
         </p:txBody>
       </p:sp>
@@ -2702,7 +2704,7 @@
             <a:fld id="{1D8BD707-D9CF-40AE-B4C6-C98DA3205C09}" type="datetimeFigureOut">
               <a:rPr lang="en-US" smtClean="0"/>
               <a:pPr/>
-              <a:t>8/1/2011</a:t>
+              <a:t>9/29/2026</a:t>
             </a:fld>
             <a:endParaRPr lang="en-US"/>
           </a:p>
@@ -2781,7 +2783,7 @@
             <a:fld id="{B6F15528-21DE-4FAA-801E-634DDDAF4B2B}" type="slidenum">
               <a:rPr lang="en-US" smtClean="0"/>
               <a:pPr/>
-              <a:t>‹#›</a:t>
+              <a:t>‹Nº›</a:t>
             </a:fld>
             <a:endParaRPr lang="en-US"/>
           </a:p>
@@ -3057,7 +3059,7 @@
 </file>
 
 <file path=ppt/slides/slide1.xml><?xml version="1.0" encoding="utf-8"?>
-<p:sld xmlns:p="http://schemas.openxmlformats.org/presentationml/2006/main" xmlns:a="http://schemas.openxmlformats.org/drawingml/2006/main" xmlns:r="http://schemas.openxmlformats.org/officeDocument/2006/relationships">
+<p:sld xmlns:a="http://schemas.openxmlformats.org/drawingml/2006/main" xmlns:r="http://schemas.openxmlformats.org/officeDocument/2006/relationships" xmlns:p="http://schemas.openxmlformats.org/presentationml/2006/main">
   <p:cSld>
     <p:spTree>
       <p:nvGrpSpPr>
@@ -3075,12 +3077,12 @@
       </p:grpSpPr>
       <p:sp>
         <p:nvSpPr>
-          <p:cNvPr name="Freeform 2" id="2"/>
+          <p:cNvPr id="2" name="Freeform 2"/>
           <p:cNvSpPr/>
           <p:nvPr/>
         </p:nvSpPr>
         <p:spPr>
-          <a:xfrm flipH="false" flipV="false" rot="0">
+          <a:xfrm>
             <a:off x="8203675" y="466939"/>
             <a:ext cx="1779422" cy="1550818"/>
           </a:xfrm>
@@ -3089,9 +3091,9 @@
             <a:gdLst/>
             <a:ahLst/>
             <a:cxnLst/>
-            <a:rect r="r" b="b" t="t" l="l"/>
+            <a:rect l="l" t="t" r="r" b="b"/>
             <a:pathLst>
-              <a:path h="1550818" w="1779422">
+              <a:path w="1779422" h="1550818">
                 <a:moveTo>
                   <a:pt x="0" y="0"/>
                 </a:moveTo>
@@ -3121,21 +3123,21 @@
       </p:sp>
       <p:sp>
         <p:nvSpPr>
-          <p:cNvPr name="TextBox 3" id="3"/>
-          <p:cNvSpPr txBox="true"/>
+          <p:cNvPr id="3" name="TextBox 3"/>
+          <p:cNvSpPr txBox="1"/>
           <p:nvPr/>
         </p:nvSpPr>
         <p:spPr>
-          <a:xfrm rot="0">
+          <a:xfrm>
             <a:off x="756000" y="2411348"/>
-            <a:ext cx="9304971" cy="2793877"/>
+            <a:ext cx="9304971" cy="2564805"/>
           </a:xfrm>
           <a:prstGeom prst="rect">
             <a:avLst/>
           </a:prstGeom>
         </p:spPr>
         <p:txBody>
-          <a:bodyPr anchor="t" rtlCol="false" tIns="0" lIns="0" bIns="0" rIns="0">
+          <a:bodyPr lIns="0" tIns="0" rIns="0" bIns="0" rtlCol="0" anchor="t">
             <a:spAutoFit/>
           </a:bodyPr>
           <a:lstStyle/>
@@ -3146,31 +3148,31 @@
               </a:lnSpc>
             </a:pPr>
             <a:r>
-              <a:rPr lang="en-US" sz="1723" i="true" spc="113">
-                <a:solidFill>
-                  <a:srgbClr val="000000"/>
-                </a:solidFill>
-                <a:latin typeface="Times New Roman MT Italics"/>
-                <a:ea typeface="Times New Roman MT Italics"/>
-                <a:cs typeface="Times New Roman MT Italics"/>
-                <a:sym typeface="Times New Roman MT Italics"/>
-              </a:rPr>
-              <a:t>La Comis</a:t>
-            </a:r>
-            <a:r>
-              <a:rPr lang="en-US" sz="1723" i="true" spc="113">
-                <a:solidFill>
-                  <a:srgbClr val="000000"/>
-                </a:solidFill>
-                <a:latin typeface="Times New Roman MT Italics"/>
-                <a:ea typeface="Times New Roman MT Italics"/>
-                <a:cs typeface="Times New Roman MT Italics"/>
-                <a:sym typeface="Times New Roman MT Italics"/>
-              </a:rPr>
-              <a:t>ión</a:t>
-            </a:r>
-            <a:r>
-              <a:rPr lang="en-US" sz="1723" i="true" spc="113">
+              <a:rPr lang="en-US" sz="1723" i="1" spc="113" dirty="0">
+                <a:solidFill>
+                  <a:srgbClr val="000000"/>
+                </a:solidFill>
+                <a:latin typeface="Times New Roman MT Italics"/>
+                <a:ea typeface="Times New Roman MT Italics"/>
+                <a:cs typeface="Times New Roman MT Italics"/>
+                <a:sym typeface="Times New Roman MT Italics"/>
+              </a:rPr>
+              <a:t>La </a:t>
+            </a:r>
+            <a:r>
+              <a:rPr lang="en-US" sz="1723" i="1" spc="113" dirty="0" err="1">
+                <a:solidFill>
+                  <a:srgbClr val="000000"/>
+                </a:solidFill>
+                <a:latin typeface="Times New Roman MT Italics"/>
+                <a:ea typeface="Times New Roman MT Italics"/>
+                <a:cs typeface="Times New Roman MT Italics"/>
+                <a:sym typeface="Times New Roman MT Italics"/>
+              </a:rPr>
+              <a:t>Comisión</a:t>
+            </a:r>
+            <a:r>
+              <a:rPr lang="en-US" sz="1723" i="1" spc="113" dirty="0">
                 <a:solidFill>
                   <a:srgbClr val="000000"/>
                 </a:solidFill>
@@ -3182,88 +3184,412 @@
               <a:t> del </a:t>
             </a:r>
             <a:r>
-              <a:rPr lang="en-US" sz="1723" i="true" spc="113">
-                <a:solidFill>
-                  <a:srgbClr val="000000"/>
-                </a:solidFill>
-                <a:latin typeface="Times New Roman MT Italics"/>
-                <a:ea typeface="Times New Roman MT Italics"/>
-                <a:cs typeface="Times New Roman MT Italics"/>
-                <a:sym typeface="Times New Roman MT Italics"/>
-              </a:rPr>
-              <a:t>Arm</a:t>
-            </a:r>
-            <a:r>
-              <a:rPr lang="en-US" sz="1723" i="true" spc="113">
-                <a:solidFill>
-                  <a:srgbClr val="000000"/>
-                </a:solidFill>
-                <a:latin typeface="Times New Roman MT Italics"/>
-                <a:ea typeface="Times New Roman MT Italics"/>
-                <a:cs typeface="Times New Roman MT Italics"/>
-                <a:sym typeface="Times New Roman MT Italics"/>
-              </a:rPr>
-              <a:t>a </a:t>
-            </a:r>
-            <a:r>
-              <a:rPr lang="en-US" sz="1723" i="true" spc="113">
-                <a:solidFill>
-                  <a:srgbClr val="000000"/>
-                </a:solidFill>
-                <a:latin typeface="Times New Roman MT Italics"/>
-                <a:ea typeface="Times New Roman MT Italics"/>
-                <a:cs typeface="Times New Roman MT Italics"/>
-                <a:sym typeface="Times New Roman MT Italics"/>
-              </a:rPr>
-              <a:t>d</a:t>
-            </a:r>
-            <a:r>
-              <a:rPr lang="en-US" sz="1723" i="true" spc="113">
-                <a:solidFill>
-                  <a:srgbClr val="000000"/>
-                </a:solidFill>
-                <a:latin typeface="Times New Roman MT Italics"/>
-                <a:ea typeface="Times New Roman MT Italics"/>
-                <a:cs typeface="Times New Roman MT Italics"/>
-                <a:sym typeface="Times New Roman MT Italics"/>
-              </a:rPr>
-              <a:t>e Comun</a:t>
-            </a:r>
-            <a:r>
-              <a:rPr lang="en-US" sz="1723" i="true" spc="113">
-                <a:solidFill>
-                  <a:srgbClr val="000000"/>
-                </a:solidFill>
-                <a:latin typeface="Times New Roman MT Italics"/>
-                <a:ea typeface="Times New Roman MT Italics"/>
-                <a:cs typeface="Times New Roman MT Italics"/>
-                <a:sym typeface="Times New Roman MT Italics"/>
-              </a:rPr>
-              <a:t>icaciones e Informática "Arcángel San Gabriel" tiene el honor de saludar al Señor / a la Señora [Nombre y Apellido] (si es </a:t>
-            </a:r>
-            <a:r>
-              <a:rPr lang="en-US" sz="1723" i="true" spc="113">
-                <a:solidFill>
-                  <a:srgbClr val="000000"/>
-                </a:solidFill>
-                <a:latin typeface="Times New Roman MT Italics"/>
-                <a:ea typeface="Times New Roman MT Italics"/>
-                <a:cs typeface="Times New Roman MT Italics"/>
-                <a:sym typeface="Times New Roman MT Italics"/>
-              </a:rPr>
-              <a:t>civil) / al Señ</a:t>
-            </a:r>
-            <a:r>
-              <a:rPr lang="en-US" sz="1723" i="true" spc="113">
-                <a:solidFill>
-                  <a:srgbClr val="000000"/>
-                </a:solidFill>
-                <a:latin typeface="Times New Roman MT Italics"/>
-                <a:ea typeface="Times New Roman MT Italics"/>
-                <a:cs typeface="Times New Roman MT Italics"/>
-                <a:sym typeface="Times New Roman MT Italics"/>
-              </a:rPr>
-              <a:t>or [Grado] D. [Nombre y Apellido] (si es militar), con motivo de celebrarse el 84° Aniversario del Arma de Comunicaciones y el Día del Sistema de Computación de Datos, bajo la advocación de su Santo Patrono, San Gabriel Arcángel.</a:t>
+              <a:rPr lang="en-US" sz="1723" i="1" spc="113" dirty="0" err="1">
+                <a:solidFill>
+                  <a:srgbClr val="000000"/>
+                </a:solidFill>
+                <a:latin typeface="Times New Roman MT Italics"/>
+                <a:ea typeface="Times New Roman MT Italics"/>
+                <a:cs typeface="Times New Roman MT Italics"/>
+                <a:sym typeface="Times New Roman MT Italics"/>
+              </a:rPr>
+              <a:t>Arma</a:t>
+            </a:r>
+            <a:r>
+              <a:rPr lang="en-US" sz="1723" i="1" spc="113" dirty="0">
+                <a:solidFill>
+                  <a:srgbClr val="000000"/>
+                </a:solidFill>
+                <a:latin typeface="Times New Roman MT Italics"/>
+                <a:ea typeface="Times New Roman MT Italics"/>
+                <a:cs typeface="Times New Roman MT Italics"/>
+                <a:sym typeface="Times New Roman MT Italics"/>
+              </a:rPr>
+              <a:t> de Comunicaciones e </a:t>
+            </a:r>
+            <a:r>
+              <a:rPr lang="en-US" sz="1723" i="1" spc="113" dirty="0" err="1">
+                <a:solidFill>
+                  <a:srgbClr val="000000"/>
+                </a:solidFill>
+                <a:latin typeface="Times New Roman MT Italics"/>
+                <a:ea typeface="Times New Roman MT Italics"/>
+                <a:cs typeface="Times New Roman MT Italics"/>
+                <a:sym typeface="Times New Roman MT Italics"/>
+              </a:rPr>
+              <a:t>Informática</a:t>
+            </a:r>
+            <a:r>
+              <a:rPr lang="en-US" sz="1723" i="1" spc="113" dirty="0">
+                <a:solidFill>
+                  <a:srgbClr val="000000"/>
+                </a:solidFill>
+                <a:latin typeface="Times New Roman MT Italics"/>
+                <a:ea typeface="Times New Roman MT Italics"/>
+                <a:cs typeface="Times New Roman MT Italics"/>
+                <a:sym typeface="Times New Roman MT Italics"/>
+              </a:rPr>
+              <a:t> "</a:t>
+            </a:r>
+            <a:r>
+              <a:rPr lang="en-US" sz="1723" i="1" spc="113" dirty="0" err="1">
+                <a:solidFill>
+                  <a:srgbClr val="000000"/>
+                </a:solidFill>
+                <a:latin typeface="Times New Roman MT Italics"/>
+                <a:ea typeface="Times New Roman MT Italics"/>
+                <a:cs typeface="Times New Roman MT Italics"/>
+                <a:sym typeface="Times New Roman MT Italics"/>
+              </a:rPr>
+              <a:t>Arcángel</a:t>
+            </a:r>
+            <a:r>
+              <a:rPr lang="en-US" sz="1723" i="1" spc="113" dirty="0">
+                <a:solidFill>
+                  <a:srgbClr val="000000"/>
+                </a:solidFill>
+                <a:latin typeface="Times New Roman MT Italics"/>
+                <a:ea typeface="Times New Roman MT Italics"/>
+                <a:cs typeface="Times New Roman MT Italics"/>
+                <a:sym typeface="Times New Roman MT Italics"/>
+              </a:rPr>
+              <a:t> San Gabriel" </a:t>
+            </a:r>
+            <a:r>
+              <a:rPr lang="en-US" sz="1723" i="1" spc="113" dirty="0" err="1">
+                <a:solidFill>
+                  <a:srgbClr val="000000"/>
+                </a:solidFill>
+                <a:latin typeface="Times New Roman MT Italics"/>
+                <a:ea typeface="Times New Roman MT Italics"/>
+                <a:cs typeface="Times New Roman MT Italics"/>
+                <a:sym typeface="Times New Roman MT Italics"/>
+              </a:rPr>
+              <a:t>tiene</a:t>
+            </a:r>
+            <a:r>
+              <a:rPr lang="en-US" sz="1723" i="1" spc="113" dirty="0">
+                <a:solidFill>
+                  <a:srgbClr val="000000"/>
+                </a:solidFill>
+                <a:latin typeface="Times New Roman MT Italics"/>
+                <a:ea typeface="Times New Roman MT Italics"/>
+                <a:cs typeface="Times New Roman MT Italics"/>
+                <a:sym typeface="Times New Roman MT Italics"/>
+              </a:rPr>
+              <a:t> el honor de </a:t>
+            </a:r>
+            <a:r>
+              <a:rPr lang="en-US" sz="1723" i="1" spc="113" dirty="0" err="1">
+                <a:solidFill>
+                  <a:srgbClr val="000000"/>
+                </a:solidFill>
+                <a:latin typeface="Times New Roman MT Italics"/>
+                <a:ea typeface="Times New Roman MT Italics"/>
+                <a:cs typeface="Times New Roman MT Italics"/>
+                <a:sym typeface="Times New Roman MT Italics"/>
+              </a:rPr>
+              <a:t>saludar</a:t>
+            </a:r>
+            <a:r>
+              <a:rPr lang="en-US" sz="1723" i="1" spc="113" dirty="0">
+                <a:solidFill>
+                  <a:srgbClr val="000000"/>
+                </a:solidFill>
+                <a:latin typeface="Times New Roman MT Italics"/>
+                <a:ea typeface="Times New Roman MT Italics"/>
+                <a:cs typeface="Times New Roman MT Italics"/>
+                <a:sym typeface="Times New Roman MT Italics"/>
+              </a:rPr>
+              <a:t> al [Grado] [</a:t>
+            </a:r>
+            <a:r>
+              <a:rPr lang="en-US" sz="1723" i="1" spc="113" dirty="0" err="1">
+                <a:solidFill>
+                  <a:srgbClr val="000000"/>
+                </a:solidFill>
+                <a:latin typeface="Times New Roman MT Italics"/>
+                <a:ea typeface="Times New Roman MT Italics"/>
+                <a:cs typeface="Times New Roman MT Italics"/>
+                <a:sym typeface="Times New Roman MT Italics"/>
+              </a:rPr>
+              <a:t>Nombre</a:t>
+            </a:r>
+            <a:r>
+              <a:rPr lang="en-US" sz="1723" i="1" spc="113" dirty="0">
+                <a:solidFill>
+                  <a:srgbClr val="000000"/>
+                </a:solidFill>
+                <a:latin typeface="Times New Roman MT Italics"/>
+                <a:ea typeface="Times New Roman MT Italics"/>
+                <a:cs typeface="Times New Roman MT Italics"/>
+                <a:sym typeface="Times New Roman MT Italics"/>
+              </a:rPr>
+              <a:t> y </a:t>
+            </a:r>
+            <a:r>
+              <a:rPr lang="en-US" sz="1723" i="1" spc="113" dirty="0" err="1">
+                <a:solidFill>
+                  <a:srgbClr val="000000"/>
+                </a:solidFill>
+                <a:latin typeface="Times New Roman MT Italics"/>
+                <a:ea typeface="Times New Roman MT Italics"/>
+                <a:cs typeface="Times New Roman MT Italics"/>
+                <a:sym typeface="Times New Roman MT Italics"/>
+              </a:rPr>
+              <a:t>Apellido</a:t>
+            </a:r>
+            <a:r>
+              <a:rPr lang="en-US" sz="1723" i="1" spc="113" dirty="0">
+                <a:solidFill>
+                  <a:srgbClr val="000000"/>
+                </a:solidFill>
+                <a:latin typeface="Times New Roman MT Italics"/>
+                <a:ea typeface="Times New Roman MT Italics"/>
+                <a:cs typeface="Times New Roman MT Italics"/>
+                <a:sym typeface="Times New Roman MT Italics"/>
+              </a:rPr>
+              <a:t>], con </a:t>
+            </a:r>
+            <a:r>
+              <a:rPr lang="en-US" sz="1723" i="1" spc="113" dirty="0" err="1">
+                <a:solidFill>
+                  <a:srgbClr val="000000"/>
+                </a:solidFill>
+                <a:latin typeface="Times New Roman MT Italics"/>
+                <a:ea typeface="Times New Roman MT Italics"/>
+                <a:cs typeface="Times New Roman MT Italics"/>
+                <a:sym typeface="Times New Roman MT Italics"/>
+              </a:rPr>
+              <a:t>motivo</a:t>
+            </a:r>
+            <a:r>
+              <a:rPr lang="en-US" sz="1723" i="1" spc="113" dirty="0">
+                <a:solidFill>
+                  <a:srgbClr val="000000"/>
+                </a:solidFill>
+                <a:latin typeface="Times New Roman MT Italics"/>
+                <a:ea typeface="Times New Roman MT Italics"/>
+                <a:cs typeface="Times New Roman MT Italics"/>
+                <a:sym typeface="Times New Roman MT Italics"/>
+              </a:rPr>
+              <a:t> de </a:t>
+            </a:r>
+            <a:r>
+              <a:rPr lang="en-US" sz="1723" i="1" spc="113" dirty="0" err="1">
+                <a:solidFill>
+                  <a:srgbClr val="000000"/>
+                </a:solidFill>
+                <a:latin typeface="Times New Roman MT Italics"/>
+                <a:ea typeface="Times New Roman MT Italics"/>
+                <a:cs typeface="Times New Roman MT Italics"/>
+                <a:sym typeface="Times New Roman MT Italics"/>
+              </a:rPr>
+              <a:t>celebrarse</a:t>
+            </a:r>
+            <a:r>
+              <a:rPr lang="en-US" sz="1723" i="1" spc="113" dirty="0">
+                <a:solidFill>
+                  <a:srgbClr val="000000"/>
+                </a:solidFill>
+                <a:latin typeface="Times New Roman MT Italics"/>
+                <a:ea typeface="Times New Roman MT Italics"/>
+                <a:cs typeface="Times New Roman MT Italics"/>
+                <a:sym typeface="Times New Roman MT Italics"/>
+              </a:rPr>
+              <a:t> el 84° </a:t>
+            </a:r>
+            <a:r>
+              <a:rPr lang="en-US" sz="1723" i="1" spc="113" dirty="0" err="1">
+                <a:solidFill>
+                  <a:srgbClr val="000000"/>
+                </a:solidFill>
+                <a:latin typeface="Times New Roman MT Italics"/>
+                <a:ea typeface="Times New Roman MT Italics"/>
+                <a:cs typeface="Times New Roman MT Italics"/>
+                <a:sym typeface="Times New Roman MT Italics"/>
+              </a:rPr>
+              <a:t>Aniversario</a:t>
+            </a:r>
+            <a:r>
+              <a:rPr lang="en-US" sz="1723" i="1" spc="113" dirty="0">
+                <a:solidFill>
+                  <a:srgbClr val="000000"/>
+                </a:solidFill>
+                <a:latin typeface="Times New Roman MT Italics"/>
+                <a:ea typeface="Times New Roman MT Italics"/>
+                <a:cs typeface="Times New Roman MT Italics"/>
+                <a:sym typeface="Times New Roman MT Italics"/>
+              </a:rPr>
+              <a:t> del </a:t>
+            </a:r>
+            <a:r>
+              <a:rPr lang="en-US" sz="1723" i="1" spc="113" dirty="0" err="1">
+                <a:solidFill>
+                  <a:srgbClr val="000000"/>
+                </a:solidFill>
+                <a:latin typeface="Times New Roman MT Italics"/>
+                <a:ea typeface="Times New Roman MT Italics"/>
+                <a:cs typeface="Times New Roman MT Italics"/>
+                <a:sym typeface="Times New Roman MT Italics"/>
+              </a:rPr>
+              <a:t>Arma</a:t>
+            </a:r>
+            <a:r>
+              <a:rPr lang="en-US" sz="1723" i="1" spc="113" dirty="0">
+                <a:solidFill>
+                  <a:srgbClr val="000000"/>
+                </a:solidFill>
+                <a:latin typeface="Times New Roman MT Italics"/>
+                <a:ea typeface="Times New Roman MT Italics"/>
+                <a:cs typeface="Times New Roman MT Italics"/>
+                <a:sym typeface="Times New Roman MT Italics"/>
+              </a:rPr>
+              <a:t> de Comunicaciones y el Día del Sistema de </a:t>
+            </a:r>
+            <a:r>
+              <a:rPr lang="en-US" sz="1723" i="1" spc="113" dirty="0" err="1">
+                <a:solidFill>
+                  <a:srgbClr val="000000"/>
+                </a:solidFill>
+                <a:latin typeface="Times New Roman MT Italics"/>
+                <a:ea typeface="Times New Roman MT Italics"/>
+                <a:cs typeface="Times New Roman MT Italics"/>
+                <a:sym typeface="Times New Roman MT Italics"/>
+              </a:rPr>
+              <a:t>Computación</a:t>
+            </a:r>
+            <a:r>
+              <a:rPr lang="en-US" sz="1723" i="1" spc="113" dirty="0">
+                <a:solidFill>
+                  <a:srgbClr val="000000"/>
+                </a:solidFill>
+                <a:latin typeface="Times New Roman MT Italics"/>
+                <a:ea typeface="Times New Roman MT Italics"/>
+                <a:cs typeface="Times New Roman MT Italics"/>
+                <a:sym typeface="Times New Roman MT Italics"/>
+              </a:rPr>
+              <a:t> de </a:t>
+            </a:r>
+            <a:r>
+              <a:rPr lang="en-US" sz="1723" i="1" spc="113" dirty="0" err="1">
+                <a:solidFill>
+                  <a:srgbClr val="000000"/>
+                </a:solidFill>
+                <a:latin typeface="Times New Roman MT Italics"/>
+                <a:ea typeface="Times New Roman MT Italics"/>
+                <a:cs typeface="Times New Roman MT Italics"/>
+                <a:sym typeface="Times New Roman MT Italics"/>
+              </a:rPr>
+              <a:t>Datos</a:t>
+            </a:r>
+            <a:r>
+              <a:rPr lang="en-US" sz="1723" i="1" spc="113" dirty="0">
+                <a:solidFill>
+                  <a:srgbClr val="000000"/>
+                </a:solidFill>
+                <a:latin typeface="Times New Roman MT Italics"/>
+                <a:ea typeface="Times New Roman MT Italics"/>
+                <a:cs typeface="Times New Roman MT Italics"/>
+                <a:sym typeface="Times New Roman MT Italics"/>
+              </a:rPr>
+              <a:t>, bajo la </a:t>
+            </a:r>
+            <a:r>
+              <a:rPr lang="en-US" sz="1723" i="1" spc="113" dirty="0" err="1">
+                <a:solidFill>
+                  <a:srgbClr val="000000"/>
+                </a:solidFill>
+                <a:latin typeface="Times New Roman MT Italics"/>
+                <a:ea typeface="Times New Roman MT Italics"/>
+                <a:cs typeface="Times New Roman MT Italics"/>
+                <a:sym typeface="Times New Roman MT Italics"/>
+              </a:rPr>
+              <a:t>advocación</a:t>
+            </a:r>
+            <a:r>
+              <a:rPr lang="en-US" sz="1723" i="1" spc="113" dirty="0">
+                <a:solidFill>
+                  <a:srgbClr val="000000"/>
+                </a:solidFill>
+                <a:latin typeface="Times New Roman MT Italics"/>
+                <a:ea typeface="Times New Roman MT Italics"/>
+                <a:cs typeface="Times New Roman MT Italics"/>
+                <a:sym typeface="Times New Roman MT Italics"/>
+              </a:rPr>
+              <a:t> de </a:t>
+            </a:r>
+            <a:r>
+              <a:rPr lang="en-US" sz="1723" i="1" spc="113" dirty="0" err="1">
+                <a:solidFill>
+                  <a:srgbClr val="000000"/>
+                </a:solidFill>
+                <a:latin typeface="Times New Roman MT Italics"/>
+                <a:ea typeface="Times New Roman MT Italics"/>
+                <a:cs typeface="Times New Roman MT Italics"/>
+                <a:sym typeface="Times New Roman MT Italics"/>
+              </a:rPr>
+              <a:t>su</a:t>
+            </a:r>
+            <a:r>
+              <a:rPr lang="en-US" sz="1723" i="1" spc="113" dirty="0">
+                <a:solidFill>
+                  <a:srgbClr val="000000"/>
+                </a:solidFill>
+                <a:latin typeface="Times New Roman MT Italics"/>
+                <a:ea typeface="Times New Roman MT Italics"/>
+                <a:cs typeface="Times New Roman MT Italics"/>
+                <a:sym typeface="Times New Roman MT Italics"/>
+              </a:rPr>
+              <a:t> Santo </a:t>
+            </a:r>
+            <a:r>
+              <a:rPr lang="en-US" sz="1723" i="1" spc="113" dirty="0" err="1">
+                <a:solidFill>
+                  <a:srgbClr val="000000"/>
+                </a:solidFill>
+                <a:latin typeface="Times New Roman MT Italics"/>
+                <a:ea typeface="Times New Roman MT Italics"/>
+                <a:cs typeface="Times New Roman MT Italics"/>
+                <a:sym typeface="Times New Roman MT Italics"/>
+              </a:rPr>
+              <a:t>Patrono</a:t>
+            </a:r>
+            <a:r>
+              <a:rPr lang="en-US" sz="1723" i="1" spc="113" dirty="0">
+                <a:solidFill>
+                  <a:srgbClr val="000000"/>
+                </a:solidFill>
+                <a:latin typeface="Times New Roman MT Italics"/>
+                <a:ea typeface="Times New Roman MT Italics"/>
+                <a:cs typeface="Times New Roman MT Italics"/>
+                <a:sym typeface="Times New Roman MT Italics"/>
+              </a:rPr>
+              <a:t>, San Gabriel </a:t>
+            </a:r>
+            <a:r>
+              <a:rPr lang="en-US" sz="1723" i="1" spc="113" dirty="0" err="1">
+                <a:solidFill>
+                  <a:srgbClr val="000000"/>
+                </a:solidFill>
+                <a:latin typeface="Times New Roman MT Italics"/>
+                <a:ea typeface="Times New Roman MT Italics"/>
+                <a:cs typeface="Times New Roman MT Italics"/>
+                <a:sym typeface="Times New Roman MT Italics"/>
+              </a:rPr>
+              <a:t>Arcángel</a:t>
+            </a:r>
+            <a:r>
+              <a:rPr lang="en-US" sz="1723" i="1" spc="113" dirty="0">
+                <a:solidFill>
+                  <a:srgbClr val="000000"/>
+                </a:solidFill>
+                <a:latin typeface="Times New Roman MT Italics"/>
+                <a:ea typeface="Times New Roman MT Italics"/>
+                <a:cs typeface="Times New Roman MT Italics"/>
+                <a:sym typeface="Times New Roman MT Italics"/>
+              </a:rPr>
+              <a:t>.</a:t>
             </a:r>
           </a:p>
           <a:p>
@@ -3272,6 +3598,15 @@
                 <a:spcPts val="1998"/>
               </a:lnSpc>
             </a:pPr>
+            <a:endParaRPr lang="en-US" sz="1723" i="1" spc="113" dirty="0">
+              <a:solidFill>
+                <a:srgbClr val="000000"/>
+              </a:solidFill>
+              <a:latin typeface="Times New Roman MT Italics"/>
+              <a:ea typeface="Times New Roman MT Italics"/>
+              <a:cs typeface="Times New Roman MT Italics"/>
+              <a:sym typeface="Times New Roman MT Italics"/>
+            </a:endParaRPr>
           </a:p>
           <a:p>
             <a:pPr algn="just">
@@ -3280,28 +3615,700 @@
               </a:lnSpc>
             </a:pPr>
             <a:r>
-              <a:rPr lang="en-US" sz="1723" i="true" spc="113">
-                <a:solidFill>
-                  <a:srgbClr val="000000"/>
-                </a:solidFill>
-                <a:latin typeface="Times New Roman MT Italics"/>
-                <a:ea typeface="Times New Roman MT Italics"/>
-                <a:cs typeface="Times New Roman MT Italics"/>
-                <a:sym typeface="Times New Roman MT Italics"/>
-              </a:rPr>
-              <a:t>Asimismo, le expresa su sincero agradecimiento por su presencia en la Ceremonia Central, realizada el 2 de octubre de 2026 en la Guarnición Ejército</a:t>
-            </a:r>
-            <a:r>
-              <a:rPr lang="en-US" sz="1723" i="true" spc="113">
-                <a:solidFill>
-                  <a:srgbClr val="000000"/>
-                </a:solidFill>
-                <a:latin typeface="Times New Roman MT Italics"/>
-                <a:ea typeface="Times New Roman MT Italics"/>
-                <a:cs typeface="Times New Roman MT Italics"/>
-                <a:sym typeface="Times New Roman MT Italics"/>
-              </a:rPr>
-              <a:t> "Córdoba", cuyo realce fue posible gracias al acompañamiento de quienes, como usted, honran con su presencia la historia y el espíritu de nuestra Arma.</a:t>
+              <a:rPr lang="en-US" sz="1723" i="1" spc="113" dirty="0" err="1">
+                <a:solidFill>
+                  <a:srgbClr val="000000"/>
+                </a:solidFill>
+                <a:latin typeface="Times New Roman MT Italics"/>
+                <a:ea typeface="Times New Roman MT Italics"/>
+                <a:cs typeface="Times New Roman MT Italics"/>
+                <a:sym typeface="Times New Roman MT Italics"/>
+              </a:rPr>
+              <a:t>Asimismo</a:t>
+            </a:r>
+            <a:r>
+              <a:rPr lang="en-US" sz="1723" i="1" spc="113" dirty="0">
+                <a:solidFill>
+                  <a:srgbClr val="000000"/>
+                </a:solidFill>
+                <a:latin typeface="Times New Roman MT Italics"/>
+                <a:ea typeface="Times New Roman MT Italics"/>
+                <a:cs typeface="Times New Roman MT Italics"/>
+                <a:sym typeface="Times New Roman MT Italics"/>
+              </a:rPr>
+              <a:t>, le </a:t>
+            </a:r>
+            <a:r>
+              <a:rPr lang="en-US" sz="1723" i="1" spc="113" dirty="0" err="1">
+                <a:solidFill>
+                  <a:srgbClr val="000000"/>
+                </a:solidFill>
+                <a:latin typeface="Times New Roman MT Italics"/>
+                <a:ea typeface="Times New Roman MT Italics"/>
+                <a:cs typeface="Times New Roman MT Italics"/>
+                <a:sym typeface="Times New Roman MT Italics"/>
+              </a:rPr>
+              <a:t>expresa</a:t>
+            </a:r>
+            <a:r>
+              <a:rPr lang="en-US" sz="1723" i="1" spc="113" dirty="0">
+                <a:solidFill>
+                  <a:srgbClr val="000000"/>
+                </a:solidFill>
+                <a:latin typeface="Times New Roman MT Italics"/>
+                <a:ea typeface="Times New Roman MT Italics"/>
+                <a:cs typeface="Times New Roman MT Italics"/>
+                <a:sym typeface="Times New Roman MT Italics"/>
+              </a:rPr>
+              <a:t> </a:t>
+            </a:r>
+            <a:r>
+              <a:rPr lang="en-US" sz="1723" i="1" spc="113" dirty="0" err="1">
+                <a:solidFill>
+                  <a:srgbClr val="000000"/>
+                </a:solidFill>
+                <a:latin typeface="Times New Roman MT Italics"/>
+                <a:ea typeface="Times New Roman MT Italics"/>
+                <a:cs typeface="Times New Roman MT Italics"/>
+                <a:sym typeface="Times New Roman MT Italics"/>
+              </a:rPr>
+              <a:t>su</a:t>
+            </a:r>
+            <a:r>
+              <a:rPr lang="en-US" sz="1723" i="1" spc="113" dirty="0">
+                <a:solidFill>
+                  <a:srgbClr val="000000"/>
+                </a:solidFill>
+                <a:latin typeface="Times New Roman MT Italics"/>
+                <a:ea typeface="Times New Roman MT Italics"/>
+                <a:cs typeface="Times New Roman MT Italics"/>
+                <a:sym typeface="Times New Roman MT Italics"/>
+              </a:rPr>
+              <a:t> </a:t>
+            </a:r>
+            <a:r>
+              <a:rPr lang="en-US" sz="1723" i="1" spc="113" dirty="0" err="1">
+                <a:solidFill>
+                  <a:srgbClr val="000000"/>
+                </a:solidFill>
+                <a:latin typeface="Times New Roman MT Italics"/>
+                <a:ea typeface="Times New Roman MT Italics"/>
+                <a:cs typeface="Times New Roman MT Italics"/>
+                <a:sym typeface="Times New Roman MT Italics"/>
+              </a:rPr>
+              <a:t>sincero</a:t>
+            </a:r>
+            <a:r>
+              <a:rPr lang="en-US" sz="1723" i="1" spc="113" dirty="0">
+                <a:solidFill>
+                  <a:srgbClr val="000000"/>
+                </a:solidFill>
+                <a:latin typeface="Times New Roman MT Italics"/>
+                <a:ea typeface="Times New Roman MT Italics"/>
+                <a:cs typeface="Times New Roman MT Italics"/>
+                <a:sym typeface="Times New Roman MT Italics"/>
+              </a:rPr>
+              <a:t> </a:t>
+            </a:r>
+            <a:r>
+              <a:rPr lang="en-US" sz="1723" i="1" spc="113" dirty="0" err="1">
+                <a:solidFill>
+                  <a:srgbClr val="000000"/>
+                </a:solidFill>
+                <a:latin typeface="Times New Roman MT Italics"/>
+                <a:ea typeface="Times New Roman MT Italics"/>
+                <a:cs typeface="Times New Roman MT Italics"/>
+                <a:sym typeface="Times New Roman MT Italics"/>
+              </a:rPr>
+              <a:t>agradecimiento</a:t>
+            </a:r>
+            <a:r>
+              <a:rPr lang="en-US" sz="1723" i="1" spc="113" dirty="0">
+                <a:solidFill>
+                  <a:srgbClr val="000000"/>
+                </a:solidFill>
+                <a:latin typeface="Times New Roman MT Italics"/>
+                <a:ea typeface="Times New Roman MT Italics"/>
+                <a:cs typeface="Times New Roman MT Italics"/>
+                <a:sym typeface="Times New Roman MT Italics"/>
+              </a:rPr>
+              <a:t> por </a:t>
+            </a:r>
+            <a:r>
+              <a:rPr lang="en-US" sz="1723" i="1" spc="113" dirty="0" err="1">
+                <a:solidFill>
+                  <a:srgbClr val="000000"/>
+                </a:solidFill>
+                <a:latin typeface="Times New Roman MT Italics"/>
+                <a:ea typeface="Times New Roman MT Italics"/>
+                <a:cs typeface="Times New Roman MT Italics"/>
+                <a:sym typeface="Times New Roman MT Italics"/>
+              </a:rPr>
+              <a:t>su</a:t>
+            </a:r>
+            <a:r>
+              <a:rPr lang="en-US" sz="1723" i="1" spc="113" dirty="0">
+                <a:solidFill>
+                  <a:srgbClr val="000000"/>
+                </a:solidFill>
+                <a:latin typeface="Times New Roman MT Italics"/>
+                <a:ea typeface="Times New Roman MT Italics"/>
+                <a:cs typeface="Times New Roman MT Italics"/>
+                <a:sym typeface="Times New Roman MT Italics"/>
+              </a:rPr>
+              <a:t> </a:t>
+            </a:r>
+            <a:r>
+              <a:rPr lang="en-US" sz="1723" i="1" spc="113" dirty="0" err="1">
+                <a:solidFill>
+                  <a:srgbClr val="000000"/>
+                </a:solidFill>
+                <a:latin typeface="Times New Roman MT Italics"/>
+                <a:ea typeface="Times New Roman MT Italics"/>
+                <a:cs typeface="Times New Roman MT Italics"/>
+                <a:sym typeface="Times New Roman MT Italics"/>
+              </a:rPr>
+              <a:t>presencia</a:t>
+            </a:r>
+            <a:r>
+              <a:rPr lang="en-US" sz="1723" i="1" spc="113" dirty="0">
+                <a:solidFill>
+                  <a:srgbClr val="000000"/>
+                </a:solidFill>
+                <a:latin typeface="Times New Roman MT Italics"/>
+                <a:ea typeface="Times New Roman MT Italics"/>
+                <a:cs typeface="Times New Roman MT Italics"/>
+                <a:sym typeface="Times New Roman MT Italics"/>
+              </a:rPr>
+              <a:t> </a:t>
+            </a:r>
+            <a:r>
+              <a:rPr lang="en-US" sz="1723" i="1" spc="113" dirty="0" err="1">
+                <a:solidFill>
+                  <a:srgbClr val="000000"/>
+                </a:solidFill>
+                <a:latin typeface="Times New Roman MT Italics"/>
+                <a:ea typeface="Times New Roman MT Italics"/>
+                <a:cs typeface="Times New Roman MT Italics"/>
+                <a:sym typeface="Times New Roman MT Italics"/>
+              </a:rPr>
+              <a:t>en</a:t>
+            </a:r>
+            <a:r>
+              <a:rPr lang="en-US" sz="1723" i="1" spc="113" dirty="0">
+                <a:solidFill>
+                  <a:srgbClr val="000000"/>
+                </a:solidFill>
+                <a:latin typeface="Times New Roman MT Italics"/>
+                <a:ea typeface="Times New Roman MT Italics"/>
+                <a:cs typeface="Times New Roman MT Italics"/>
+                <a:sym typeface="Times New Roman MT Italics"/>
+              </a:rPr>
+              <a:t> la </a:t>
+            </a:r>
+            <a:r>
+              <a:rPr lang="en-US" sz="1723" i="1" spc="113" dirty="0" err="1">
+                <a:solidFill>
+                  <a:srgbClr val="000000"/>
+                </a:solidFill>
+                <a:latin typeface="Times New Roman MT Italics"/>
+                <a:ea typeface="Times New Roman MT Italics"/>
+                <a:cs typeface="Times New Roman MT Italics"/>
+                <a:sym typeface="Times New Roman MT Italics"/>
+              </a:rPr>
+              <a:t>Ceremonia</a:t>
+            </a:r>
+            <a:r>
+              <a:rPr lang="en-US" sz="1723" i="1" spc="113" dirty="0">
+                <a:solidFill>
+                  <a:srgbClr val="000000"/>
+                </a:solidFill>
+                <a:latin typeface="Times New Roman MT Italics"/>
+                <a:ea typeface="Times New Roman MT Italics"/>
+                <a:cs typeface="Times New Roman MT Italics"/>
+                <a:sym typeface="Times New Roman MT Italics"/>
+              </a:rPr>
+              <a:t> Central, </a:t>
+            </a:r>
+            <a:r>
+              <a:rPr lang="en-US" sz="1723" i="1" spc="113" dirty="0" err="1">
+                <a:solidFill>
+                  <a:srgbClr val="000000"/>
+                </a:solidFill>
+                <a:latin typeface="Times New Roman MT Italics"/>
+                <a:ea typeface="Times New Roman MT Italics"/>
+                <a:cs typeface="Times New Roman MT Italics"/>
+                <a:sym typeface="Times New Roman MT Italics"/>
+              </a:rPr>
+              <a:t>realizada</a:t>
+            </a:r>
+            <a:r>
+              <a:rPr lang="en-US" sz="1723" i="1" spc="113" dirty="0">
+                <a:solidFill>
+                  <a:srgbClr val="000000"/>
+                </a:solidFill>
+                <a:latin typeface="Times New Roman MT Italics"/>
+                <a:ea typeface="Times New Roman MT Italics"/>
+                <a:cs typeface="Times New Roman MT Italics"/>
+                <a:sym typeface="Times New Roman MT Italics"/>
+              </a:rPr>
+              <a:t> el 2 de </a:t>
+            </a:r>
+            <a:r>
+              <a:rPr lang="en-US" sz="1723" i="1" spc="113" dirty="0" err="1">
+                <a:solidFill>
+                  <a:srgbClr val="000000"/>
+                </a:solidFill>
+                <a:latin typeface="Times New Roman MT Italics"/>
+                <a:ea typeface="Times New Roman MT Italics"/>
+                <a:cs typeface="Times New Roman MT Italics"/>
+                <a:sym typeface="Times New Roman MT Italics"/>
+              </a:rPr>
+              <a:t>octubre</a:t>
+            </a:r>
+            <a:r>
+              <a:rPr lang="en-US" sz="1723" i="1" spc="113" dirty="0">
+                <a:solidFill>
+                  <a:srgbClr val="000000"/>
+                </a:solidFill>
+                <a:latin typeface="Times New Roman MT Italics"/>
+                <a:ea typeface="Times New Roman MT Italics"/>
+                <a:cs typeface="Times New Roman MT Italics"/>
+                <a:sym typeface="Times New Roman MT Italics"/>
+              </a:rPr>
+              <a:t> de 2026 </a:t>
+            </a:r>
+            <a:r>
+              <a:rPr lang="en-US" sz="1723" i="1" spc="113" dirty="0" err="1">
+                <a:solidFill>
+                  <a:srgbClr val="000000"/>
+                </a:solidFill>
+                <a:latin typeface="Times New Roman MT Italics"/>
+                <a:ea typeface="Times New Roman MT Italics"/>
+                <a:cs typeface="Times New Roman MT Italics"/>
+                <a:sym typeface="Times New Roman MT Italics"/>
+              </a:rPr>
+              <a:t>en</a:t>
+            </a:r>
+            <a:r>
+              <a:rPr lang="en-US" sz="1723" i="1" spc="113" dirty="0">
+                <a:solidFill>
+                  <a:srgbClr val="000000"/>
+                </a:solidFill>
+                <a:latin typeface="Times New Roman MT Italics"/>
+                <a:ea typeface="Times New Roman MT Italics"/>
+                <a:cs typeface="Times New Roman MT Italics"/>
+                <a:sym typeface="Times New Roman MT Italics"/>
+              </a:rPr>
+              <a:t> la </a:t>
+            </a:r>
+            <a:r>
+              <a:rPr lang="en-US" sz="1723" i="1" spc="113" dirty="0" err="1">
+                <a:solidFill>
+                  <a:srgbClr val="000000"/>
+                </a:solidFill>
+                <a:latin typeface="Times New Roman MT Italics"/>
+                <a:ea typeface="Times New Roman MT Italics"/>
+                <a:cs typeface="Times New Roman MT Italics"/>
+                <a:sym typeface="Times New Roman MT Italics"/>
+              </a:rPr>
+              <a:t>Guarnición</a:t>
+            </a:r>
+            <a:r>
+              <a:rPr lang="en-US" sz="1723" i="1" spc="113" dirty="0">
+                <a:solidFill>
+                  <a:srgbClr val="000000"/>
+                </a:solidFill>
+                <a:latin typeface="Times New Roman MT Italics"/>
+                <a:ea typeface="Times New Roman MT Italics"/>
+                <a:cs typeface="Times New Roman MT Italics"/>
+                <a:sym typeface="Times New Roman MT Italics"/>
+              </a:rPr>
+              <a:t> </a:t>
+            </a:r>
+            <a:r>
+              <a:rPr lang="en-US" sz="1723" i="1" spc="113" dirty="0" err="1">
+                <a:solidFill>
+                  <a:srgbClr val="000000"/>
+                </a:solidFill>
+                <a:latin typeface="Times New Roman MT Italics"/>
+                <a:ea typeface="Times New Roman MT Italics"/>
+                <a:cs typeface="Times New Roman MT Italics"/>
+                <a:sym typeface="Times New Roman MT Italics"/>
+              </a:rPr>
+              <a:t>Ejército</a:t>
+            </a:r>
+            <a:r>
+              <a:rPr lang="en-US" sz="1723" i="1" spc="113" dirty="0">
+                <a:solidFill>
+                  <a:srgbClr val="000000"/>
+                </a:solidFill>
+                <a:latin typeface="Times New Roman MT Italics"/>
+                <a:ea typeface="Times New Roman MT Italics"/>
+                <a:cs typeface="Times New Roman MT Italics"/>
+                <a:sym typeface="Times New Roman MT Italics"/>
+              </a:rPr>
+              <a:t> "Córdoba", </a:t>
+            </a:r>
+            <a:r>
+              <a:rPr lang="en-US" sz="1723" i="1" spc="113" dirty="0" err="1">
+                <a:solidFill>
+                  <a:srgbClr val="000000"/>
+                </a:solidFill>
+                <a:latin typeface="Times New Roman MT Italics"/>
+                <a:ea typeface="Times New Roman MT Italics"/>
+                <a:cs typeface="Times New Roman MT Italics"/>
+                <a:sym typeface="Times New Roman MT Italics"/>
+              </a:rPr>
+              <a:t>cuyo</a:t>
+            </a:r>
+            <a:r>
+              <a:rPr lang="en-US" sz="1723" i="1" spc="113" dirty="0">
+                <a:solidFill>
+                  <a:srgbClr val="000000"/>
+                </a:solidFill>
+                <a:latin typeface="Times New Roman MT Italics"/>
+                <a:ea typeface="Times New Roman MT Italics"/>
+                <a:cs typeface="Times New Roman MT Italics"/>
+                <a:sym typeface="Times New Roman MT Italics"/>
+              </a:rPr>
+              <a:t> </a:t>
+            </a:r>
+            <a:r>
+              <a:rPr lang="en-US" sz="1723" i="1" spc="113" dirty="0" err="1">
+                <a:solidFill>
+                  <a:srgbClr val="000000"/>
+                </a:solidFill>
+                <a:latin typeface="Times New Roman MT Italics"/>
+                <a:ea typeface="Times New Roman MT Italics"/>
+                <a:cs typeface="Times New Roman MT Italics"/>
+                <a:sym typeface="Times New Roman MT Italics"/>
+              </a:rPr>
+              <a:t>realce</a:t>
+            </a:r>
+            <a:r>
+              <a:rPr lang="en-US" sz="1723" i="1" spc="113" dirty="0">
+                <a:solidFill>
+                  <a:srgbClr val="000000"/>
+                </a:solidFill>
+                <a:latin typeface="Times New Roman MT Italics"/>
+                <a:ea typeface="Times New Roman MT Italics"/>
+                <a:cs typeface="Times New Roman MT Italics"/>
+                <a:sym typeface="Times New Roman MT Italics"/>
+              </a:rPr>
+              <a:t> </a:t>
+            </a:r>
+            <a:r>
+              <a:rPr lang="en-US" sz="1723" i="1" spc="113" dirty="0" err="1">
+                <a:solidFill>
+                  <a:srgbClr val="000000"/>
+                </a:solidFill>
+                <a:latin typeface="Times New Roman MT Italics"/>
+                <a:ea typeface="Times New Roman MT Italics"/>
+                <a:cs typeface="Times New Roman MT Italics"/>
+                <a:sym typeface="Times New Roman MT Italics"/>
+              </a:rPr>
+              <a:t>fue</a:t>
+            </a:r>
+            <a:r>
+              <a:rPr lang="en-US" sz="1723" i="1" spc="113" dirty="0">
+                <a:solidFill>
+                  <a:srgbClr val="000000"/>
+                </a:solidFill>
+                <a:latin typeface="Times New Roman MT Italics"/>
+                <a:ea typeface="Times New Roman MT Italics"/>
+                <a:cs typeface="Times New Roman MT Italics"/>
+                <a:sym typeface="Times New Roman MT Italics"/>
+              </a:rPr>
+              <a:t> </a:t>
+            </a:r>
+            <a:r>
+              <a:rPr lang="en-US" sz="1723" i="1" spc="113" dirty="0" err="1">
+                <a:solidFill>
+                  <a:srgbClr val="000000"/>
+                </a:solidFill>
+                <a:latin typeface="Times New Roman MT Italics"/>
+                <a:ea typeface="Times New Roman MT Italics"/>
+                <a:cs typeface="Times New Roman MT Italics"/>
+                <a:sym typeface="Times New Roman MT Italics"/>
+              </a:rPr>
+              <a:t>posible</a:t>
+            </a:r>
+            <a:r>
+              <a:rPr lang="en-US" sz="1723" i="1" spc="113" dirty="0">
+                <a:solidFill>
+                  <a:srgbClr val="000000"/>
+                </a:solidFill>
+                <a:latin typeface="Times New Roman MT Italics"/>
+                <a:ea typeface="Times New Roman MT Italics"/>
+                <a:cs typeface="Times New Roman MT Italics"/>
+                <a:sym typeface="Times New Roman MT Italics"/>
+              </a:rPr>
+              <a:t> gracias al </a:t>
+            </a:r>
+            <a:r>
+              <a:rPr lang="en-US" sz="1723" i="1" spc="113" dirty="0" err="1">
+                <a:solidFill>
+                  <a:srgbClr val="000000"/>
+                </a:solidFill>
+                <a:latin typeface="Times New Roman MT Italics"/>
+                <a:ea typeface="Times New Roman MT Italics"/>
+                <a:cs typeface="Times New Roman MT Italics"/>
+                <a:sym typeface="Times New Roman MT Italics"/>
+              </a:rPr>
+              <a:t>acompañamiento</a:t>
+            </a:r>
+            <a:r>
+              <a:rPr lang="en-US" sz="1723" i="1" spc="113" dirty="0">
+                <a:solidFill>
+                  <a:srgbClr val="000000"/>
+                </a:solidFill>
+                <a:latin typeface="Times New Roman MT Italics"/>
+                <a:ea typeface="Times New Roman MT Italics"/>
+                <a:cs typeface="Times New Roman MT Italics"/>
+                <a:sym typeface="Times New Roman MT Italics"/>
+              </a:rPr>
+              <a:t> de </a:t>
+            </a:r>
+            <a:r>
+              <a:rPr lang="en-US" sz="1723" i="1" spc="113" dirty="0" err="1">
+                <a:solidFill>
+                  <a:srgbClr val="000000"/>
+                </a:solidFill>
+                <a:latin typeface="Times New Roman MT Italics"/>
+                <a:ea typeface="Times New Roman MT Italics"/>
+                <a:cs typeface="Times New Roman MT Italics"/>
+                <a:sym typeface="Times New Roman MT Italics"/>
+              </a:rPr>
+              <a:t>quienes</a:t>
+            </a:r>
+            <a:r>
+              <a:rPr lang="en-US" sz="1723" i="1" spc="113" dirty="0">
+                <a:solidFill>
+                  <a:srgbClr val="000000"/>
+                </a:solidFill>
+                <a:latin typeface="Times New Roman MT Italics"/>
+                <a:ea typeface="Times New Roman MT Italics"/>
+                <a:cs typeface="Times New Roman MT Italics"/>
+                <a:sym typeface="Times New Roman MT Italics"/>
+              </a:rPr>
+              <a:t>, </a:t>
+            </a:r>
+            <a:r>
+              <a:rPr lang="en-US" sz="1723" i="1" spc="113" dirty="0" err="1">
+                <a:solidFill>
+                  <a:srgbClr val="000000"/>
+                </a:solidFill>
+                <a:latin typeface="Times New Roman MT Italics"/>
+                <a:ea typeface="Times New Roman MT Italics"/>
+                <a:cs typeface="Times New Roman MT Italics"/>
+                <a:sym typeface="Times New Roman MT Italics"/>
+              </a:rPr>
+              <a:t>como</a:t>
+            </a:r>
+            <a:r>
+              <a:rPr lang="en-US" sz="1723" i="1" spc="113" dirty="0">
+                <a:solidFill>
+                  <a:srgbClr val="000000"/>
+                </a:solidFill>
+                <a:latin typeface="Times New Roman MT Italics"/>
+                <a:ea typeface="Times New Roman MT Italics"/>
+                <a:cs typeface="Times New Roman MT Italics"/>
+                <a:sym typeface="Times New Roman MT Italics"/>
+              </a:rPr>
+              <a:t> </a:t>
+            </a:r>
+            <a:r>
+              <a:rPr lang="en-US" sz="1723" i="1" spc="113" dirty="0" err="1">
+                <a:solidFill>
+                  <a:srgbClr val="000000"/>
+                </a:solidFill>
+                <a:latin typeface="Times New Roman MT Italics"/>
+                <a:ea typeface="Times New Roman MT Italics"/>
+                <a:cs typeface="Times New Roman MT Italics"/>
+                <a:sym typeface="Times New Roman MT Italics"/>
+              </a:rPr>
+              <a:t>usted</a:t>
+            </a:r>
+            <a:r>
+              <a:rPr lang="en-US" sz="1723" i="1" spc="113" dirty="0">
+                <a:solidFill>
+                  <a:srgbClr val="000000"/>
+                </a:solidFill>
+                <a:latin typeface="Times New Roman MT Italics"/>
+                <a:ea typeface="Times New Roman MT Italics"/>
+                <a:cs typeface="Times New Roman MT Italics"/>
+                <a:sym typeface="Times New Roman MT Italics"/>
+              </a:rPr>
+              <a:t>, </a:t>
+            </a:r>
+            <a:r>
+              <a:rPr lang="en-US" sz="1723" i="1" spc="113" dirty="0" err="1">
+                <a:solidFill>
+                  <a:srgbClr val="000000"/>
+                </a:solidFill>
+                <a:latin typeface="Times New Roman MT Italics"/>
+                <a:ea typeface="Times New Roman MT Italics"/>
+                <a:cs typeface="Times New Roman MT Italics"/>
+                <a:sym typeface="Times New Roman MT Italics"/>
+              </a:rPr>
+              <a:t>honran</a:t>
+            </a:r>
+            <a:r>
+              <a:rPr lang="en-US" sz="1723" i="1" spc="113" dirty="0">
+                <a:solidFill>
+                  <a:srgbClr val="000000"/>
+                </a:solidFill>
+                <a:latin typeface="Times New Roman MT Italics"/>
+                <a:ea typeface="Times New Roman MT Italics"/>
+                <a:cs typeface="Times New Roman MT Italics"/>
+                <a:sym typeface="Times New Roman MT Italics"/>
+              </a:rPr>
+              <a:t> con </a:t>
+            </a:r>
+            <a:r>
+              <a:rPr lang="en-US" sz="1723" i="1" spc="113" dirty="0" err="1">
+                <a:solidFill>
+                  <a:srgbClr val="000000"/>
+                </a:solidFill>
+                <a:latin typeface="Times New Roman MT Italics"/>
+                <a:ea typeface="Times New Roman MT Italics"/>
+                <a:cs typeface="Times New Roman MT Italics"/>
+                <a:sym typeface="Times New Roman MT Italics"/>
+              </a:rPr>
+              <a:t>su</a:t>
+            </a:r>
+            <a:r>
+              <a:rPr lang="en-US" sz="1723" i="1" spc="113" dirty="0">
+                <a:solidFill>
+                  <a:srgbClr val="000000"/>
+                </a:solidFill>
+                <a:latin typeface="Times New Roman MT Italics"/>
+                <a:ea typeface="Times New Roman MT Italics"/>
+                <a:cs typeface="Times New Roman MT Italics"/>
+                <a:sym typeface="Times New Roman MT Italics"/>
+              </a:rPr>
+              <a:t> </a:t>
+            </a:r>
+            <a:r>
+              <a:rPr lang="en-US" sz="1723" i="1" spc="113" dirty="0" err="1">
+                <a:solidFill>
+                  <a:srgbClr val="000000"/>
+                </a:solidFill>
+                <a:latin typeface="Times New Roman MT Italics"/>
+                <a:ea typeface="Times New Roman MT Italics"/>
+                <a:cs typeface="Times New Roman MT Italics"/>
+                <a:sym typeface="Times New Roman MT Italics"/>
+              </a:rPr>
+              <a:t>presencia</a:t>
+            </a:r>
+            <a:r>
+              <a:rPr lang="en-US" sz="1723" i="1" spc="113" dirty="0">
+                <a:solidFill>
+                  <a:srgbClr val="000000"/>
+                </a:solidFill>
+                <a:latin typeface="Times New Roman MT Italics"/>
+                <a:ea typeface="Times New Roman MT Italics"/>
+                <a:cs typeface="Times New Roman MT Italics"/>
+                <a:sym typeface="Times New Roman MT Italics"/>
+              </a:rPr>
+              <a:t> la </a:t>
+            </a:r>
+            <a:r>
+              <a:rPr lang="en-US" sz="1723" i="1" spc="113" dirty="0" err="1">
+                <a:solidFill>
+                  <a:srgbClr val="000000"/>
+                </a:solidFill>
+                <a:latin typeface="Times New Roman MT Italics"/>
+                <a:ea typeface="Times New Roman MT Italics"/>
+                <a:cs typeface="Times New Roman MT Italics"/>
+                <a:sym typeface="Times New Roman MT Italics"/>
+              </a:rPr>
+              <a:t>historia</a:t>
+            </a:r>
+            <a:r>
+              <a:rPr lang="en-US" sz="1723" i="1" spc="113" dirty="0">
+                <a:solidFill>
+                  <a:srgbClr val="000000"/>
+                </a:solidFill>
+                <a:latin typeface="Times New Roman MT Italics"/>
+                <a:ea typeface="Times New Roman MT Italics"/>
+                <a:cs typeface="Times New Roman MT Italics"/>
+                <a:sym typeface="Times New Roman MT Italics"/>
+              </a:rPr>
+              <a:t> y el </a:t>
+            </a:r>
+            <a:r>
+              <a:rPr lang="en-US" sz="1723" i="1" spc="113" dirty="0" err="1">
+                <a:solidFill>
+                  <a:srgbClr val="000000"/>
+                </a:solidFill>
+                <a:latin typeface="Times New Roman MT Italics"/>
+                <a:ea typeface="Times New Roman MT Italics"/>
+                <a:cs typeface="Times New Roman MT Italics"/>
+                <a:sym typeface="Times New Roman MT Italics"/>
+              </a:rPr>
+              <a:t>espíritu</a:t>
+            </a:r>
+            <a:r>
+              <a:rPr lang="en-US" sz="1723" i="1" spc="113" dirty="0">
+                <a:solidFill>
+                  <a:srgbClr val="000000"/>
+                </a:solidFill>
+                <a:latin typeface="Times New Roman MT Italics"/>
+                <a:ea typeface="Times New Roman MT Italics"/>
+                <a:cs typeface="Times New Roman MT Italics"/>
+                <a:sym typeface="Times New Roman MT Italics"/>
+              </a:rPr>
+              <a:t> de </a:t>
+            </a:r>
+            <a:r>
+              <a:rPr lang="en-US" sz="1723" i="1" spc="113" dirty="0" err="1">
+                <a:solidFill>
+                  <a:srgbClr val="000000"/>
+                </a:solidFill>
+                <a:latin typeface="Times New Roman MT Italics"/>
+                <a:ea typeface="Times New Roman MT Italics"/>
+                <a:cs typeface="Times New Roman MT Italics"/>
+                <a:sym typeface="Times New Roman MT Italics"/>
+              </a:rPr>
+              <a:t>nuestra</a:t>
+            </a:r>
+            <a:r>
+              <a:rPr lang="en-US" sz="1723" i="1" spc="113" dirty="0">
+                <a:solidFill>
+                  <a:srgbClr val="000000"/>
+                </a:solidFill>
+                <a:latin typeface="Times New Roman MT Italics"/>
+                <a:ea typeface="Times New Roman MT Italics"/>
+                <a:cs typeface="Times New Roman MT Italics"/>
+                <a:sym typeface="Times New Roman MT Italics"/>
+              </a:rPr>
+              <a:t> </a:t>
+            </a:r>
+            <a:r>
+              <a:rPr lang="en-US" sz="1723" i="1" spc="113" dirty="0" err="1">
+                <a:solidFill>
+                  <a:srgbClr val="000000"/>
+                </a:solidFill>
+                <a:latin typeface="Times New Roman MT Italics"/>
+                <a:ea typeface="Times New Roman MT Italics"/>
+                <a:cs typeface="Times New Roman MT Italics"/>
+                <a:sym typeface="Times New Roman MT Italics"/>
+              </a:rPr>
+              <a:t>Arma</a:t>
+            </a:r>
+            <a:r>
+              <a:rPr lang="en-US" sz="1723" i="1" spc="113" dirty="0">
+                <a:solidFill>
+                  <a:srgbClr val="000000"/>
+                </a:solidFill>
+                <a:latin typeface="Times New Roman MT Italics"/>
+                <a:ea typeface="Times New Roman MT Italics"/>
+                <a:cs typeface="Times New Roman MT Italics"/>
+                <a:sym typeface="Times New Roman MT Italics"/>
+              </a:rPr>
+              <a:t>.</a:t>
             </a:r>
           </a:p>
           <a:p>
@@ -3310,17 +4317,26 @@
                 <a:spcPts val="1998"/>
               </a:lnSpc>
             </a:pPr>
-          </a:p>
-        </p:txBody>
-      </p:sp>
-      <p:sp>
-        <p:nvSpPr>
-          <p:cNvPr name="TextBox 4" id="4"/>
-          <p:cNvSpPr txBox="true"/>
+            <a:endParaRPr lang="en-US" sz="1723" i="1" spc="113" dirty="0">
+              <a:solidFill>
+                <a:srgbClr val="000000"/>
+              </a:solidFill>
+              <a:latin typeface="Times New Roman MT Italics"/>
+              <a:ea typeface="Times New Roman MT Italics"/>
+              <a:cs typeface="Times New Roman MT Italics"/>
+              <a:sym typeface="Times New Roman MT Italics"/>
+            </a:endParaRPr>
+          </a:p>
+        </p:txBody>
+      </p:sp>
+      <p:sp>
+        <p:nvSpPr>
+          <p:cNvPr id="4" name="TextBox 4"/>
+          <p:cNvSpPr txBox="1"/>
           <p:nvPr/>
         </p:nvSpPr>
         <p:spPr>
-          <a:xfrm rot="0">
+          <a:xfrm>
             <a:off x="2780653" y="1065364"/>
             <a:ext cx="5130695" cy="394547"/>
           </a:xfrm>
@@ -3329,7 +4345,7 @@
           </a:prstGeom>
         </p:spPr>
         <p:txBody>
-          <a:bodyPr anchor="t" rtlCol="false" tIns="0" lIns="0" bIns="0" rIns="0">
+          <a:bodyPr lIns="0" tIns="0" rIns="0" bIns="0" rtlCol="0" anchor="t">
             <a:spAutoFit/>
           </a:bodyPr>
           <a:lstStyle/>
@@ -3340,7 +4356,7 @@
               </a:lnSpc>
             </a:pPr>
             <a:r>
-              <a:rPr lang="en-US" sz="1839" spc="202" b="true">
+              <a:rPr lang="en-US" sz="1839" b="1" spc="202">
                 <a:solidFill>
                   <a:srgbClr val="000000"/>
                 </a:solidFill>
@@ -3356,81 +4372,21 @@
       </p:sp>
       <p:sp>
         <p:nvSpPr>
-          <p:cNvPr name="TextBox 5" id="5"/>
-          <p:cNvSpPr txBox="true"/>
+          <p:cNvPr id="6" name="TextBox 6"/>
+          <p:cNvSpPr txBox="1"/>
           <p:nvPr/>
         </p:nvSpPr>
         <p:spPr>
-          <a:xfrm rot="0">
-            <a:off x="6471350" y="6093204"/>
-            <a:ext cx="3464650" cy="482262"/>
+          <a:xfrm>
+            <a:off x="5973094" y="5126667"/>
+            <a:ext cx="4366967" cy="283476"/>
           </a:xfrm>
           <a:prstGeom prst="rect">
             <a:avLst/>
           </a:prstGeom>
         </p:spPr>
         <p:txBody>
-          <a:bodyPr anchor="t" rtlCol="false" tIns="0" lIns="0" bIns="0" rIns="0">
-            <a:spAutoFit/>
-          </a:bodyPr>
-          <a:lstStyle/>
-          <a:p>
-            <a:pPr algn="r">
-              <a:lnSpc>
-                <a:spcPts val="1843"/>
-              </a:lnSpc>
-            </a:pPr>
-            <a:r>
-              <a:rPr lang="en-US" sz="1451" spc="169">
-                <a:solidFill>
-                  <a:srgbClr val="000000"/>
-                </a:solidFill>
-                <a:latin typeface="Times New Roman MT"/>
-                <a:ea typeface="Times New Roman MT"/>
-                <a:cs typeface="Times New Roman MT"/>
-                <a:sym typeface="Times New Roman MT"/>
-              </a:rPr>
-              <a:t>Militares: Uniforme de combate.</a:t>
-            </a:r>
-          </a:p>
-          <a:p>
-            <a:pPr algn="r">
-              <a:lnSpc>
-                <a:spcPts val="1843"/>
-              </a:lnSpc>
-            </a:pPr>
-            <a:r>
-              <a:rPr lang="en-US" sz="1451" spc="169">
-                <a:solidFill>
-                  <a:srgbClr val="000000"/>
-                </a:solidFill>
-                <a:latin typeface="Times New Roman MT"/>
-                <a:ea typeface="Times New Roman MT"/>
-                <a:cs typeface="Times New Roman MT"/>
-                <a:sym typeface="Times New Roman MT"/>
-              </a:rPr>
-              <a:t>Retirados y civiles: Elegante Sport</a:t>
-            </a:r>
-          </a:p>
-        </p:txBody>
-      </p:sp>
-      <p:sp>
-        <p:nvSpPr>
-          <p:cNvPr name="TextBox 6" id="6"/>
-          <p:cNvSpPr txBox="true"/>
-          <p:nvPr/>
-        </p:nvSpPr>
-        <p:spPr>
-          <a:xfrm rot="0">
-            <a:off x="5973094" y="5126667"/>
-            <a:ext cx="4366967" cy="315242"/>
-          </a:xfrm>
-          <a:prstGeom prst="rect">
-            <a:avLst/>
-          </a:prstGeom>
-        </p:spPr>
-        <p:txBody>
-          <a:bodyPr anchor="t" rtlCol="false" tIns="0" lIns="0" bIns="0" rIns="0">
+          <a:bodyPr lIns="0" tIns="0" rIns="0" bIns="0" rtlCol="0" anchor="t">
             <a:spAutoFit/>
           </a:bodyPr>
           <a:lstStyle/>
@@ -3441,7 +4397,7 @@
               </a:lnSpc>
             </a:pPr>
             <a:r>
-              <a:rPr lang="en-US" sz="1451" spc="159">
+              <a:rPr lang="en-US" sz="1451" spc="159" dirty="0">
                 <a:solidFill>
                   <a:srgbClr val="000000"/>
                 </a:solidFill>
@@ -3450,39 +4406,10 @@
                 <a:cs typeface="Times New Roman MT"/>
                 <a:sym typeface="Times New Roman MT"/>
               </a:rPr>
-              <a:t>C.A. Buenos Aires,      de octubre de 2026.-</a:t>
-            </a:r>
-          </a:p>
-        </p:txBody>
-      </p:sp>
-      <p:sp>
-        <p:nvSpPr>
-          <p:cNvPr name="TextBox 7" id="7"/>
-          <p:cNvSpPr txBox="true"/>
-          <p:nvPr/>
-        </p:nvSpPr>
-        <p:spPr>
-          <a:xfrm rot="0">
-            <a:off x="897192" y="6093204"/>
-            <a:ext cx="3313228" cy="482262"/>
-          </a:xfrm>
-          <a:prstGeom prst="rect">
-            <a:avLst/>
-          </a:prstGeom>
-        </p:spPr>
-        <p:txBody>
-          <a:bodyPr anchor="t" rtlCol="false" tIns="0" lIns="0" bIns="0" rIns="0">
-            <a:spAutoFit/>
-          </a:bodyPr>
-          <a:lstStyle/>
-          <a:p>
-            <a:pPr algn="r">
-              <a:lnSpc>
-                <a:spcPts val="1843"/>
-              </a:lnSpc>
-            </a:pPr>
-            <a:r>
-              <a:rPr lang="en-US" sz="1451" spc="169">
+              <a:t>C.A. Buenos Aires, 02 de </a:t>
+            </a:r>
+            <a:r>
+              <a:rPr lang="en-US" sz="1451" spc="159" dirty="0" err="1">
                 <a:solidFill>
                   <a:srgbClr val="000000"/>
                 </a:solidFill>
@@ -3491,17 +4418,10 @@
                 <a:cs typeface="Times New Roman MT"/>
                 <a:sym typeface="Times New Roman MT"/>
               </a:rPr>
-              <a:t>Azopardo 250, C.A.Buenos Aires</a:t>
-            </a:r>
-          </a:p>
-          <a:p>
-            <a:pPr algn="r">
-              <a:lnSpc>
-                <a:spcPts val="1843"/>
-              </a:lnSpc>
-            </a:pPr>
-            <a:r>
-              <a:rPr lang="en-US" sz="1451" spc="169">
+              <a:t>octubre</a:t>
+            </a:r>
+            <a:r>
+              <a:rPr lang="en-US" sz="1451" spc="159" dirty="0">
                 <a:solidFill>
                   <a:srgbClr val="000000"/>
                 </a:solidFill>
@@ -3510,19 +4430,19 @@
                 <a:cs typeface="Times New Roman MT"/>
                 <a:sym typeface="Times New Roman MT"/>
               </a:rPr>
-              <a:t>S. R. C: 4346 6100 Int 1187 </a:t>
-            </a:r>
-          </a:p>
-        </p:txBody>
-      </p:sp>
-      <p:sp>
-        <p:nvSpPr>
-          <p:cNvPr name="Freeform 8" id="8" descr="Caídos en la guerra: el Ejército desarrolló un mapa interactivo - El Litoral"/>
+              <a:t> de 2026.</a:t>
+            </a:r>
+          </a:p>
+        </p:txBody>
+      </p:sp>
+      <p:sp>
+        <p:nvSpPr>
+          <p:cNvPr id="8" name="Freeform 8" descr="Caídos en la guerra: el Ejército desarrolló un mapa interactivo - El Litoral"/>
           <p:cNvSpPr/>
           <p:nvPr/>
         </p:nvSpPr>
         <p:spPr>
-          <a:xfrm flipH="false" flipV="false" rot="0">
+          <a:xfrm>
             <a:off x="897192" y="466939"/>
             <a:ext cx="1443662" cy="1705696"/>
           </a:xfrm>
@@ -3531,9 +4451,9 @@
             <a:gdLst/>
             <a:ahLst/>
             <a:cxnLst/>
-            <a:rect r="r" b="b" t="t" l="l"/>
+            <a:rect l="l" t="t" r="r" b="b"/>
             <a:pathLst>
-              <a:path h="1705696" w="1443662">
+              <a:path w="1443662" h="1705696">
                 <a:moveTo>
                   <a:pt x="0" y="0"/>
                 </a:moveTo>
@@ -3556,7 +4476,7 @@
           <a:blipFill>
             <a:blip r:embed="rId3"/>
             <a:stretch>
-              <a:fillRect l="0" t="0" r="0" b="-198"/>
+              <a:fillRect b="-198"/>
             </a:stretch>
           </a:blipFill>
         </p:spPr>

</xml_diff>

<commit_message>
chore: initial project upload
</commit_message>
<xml_diff>
--- a/diploma/plantilla_diploma.pptx
+++ b/diploma/plantilla_diploma.pptx
@@ -324,7 +324,7 @@
             <a:fld id="{1D8BD707-D9CF-40AE-B4C6-C98DA3205C09}" type="datetimeFigureOut">
               <a:rPr lang="en-US" smtClean="0"/>
               <a:pPr/>
-              <a:t>9/29/2026</a:t>
+              <a:t>9/30/2026</a:t>
             </a:fld>
             <a:endParaRPr lang="en-US"/>
           </a:p>
@@ -489,7 +489,7 @@
             <a:fld id="{1D8BD707-D9CF-40AE-B4C6-C98DA3205C09}" type="datetimeFigureOut">
               <a:rPr lang="en-US" smtClean="0"/>
               <a:pPr/>
-              <a:t>9/29/2026</a:t>
+              <a:t>9/30/2026</a:t>
             </a:fld>
             <a:endParaRPr lang="en-US"/>
           </a:p>
@@ -664,7 +664,7 @@
             <a:fld id="{1D8BD707-D9CF-40AE-B4C6-C98DA3205C09}" type="datetimeFigureOut">
               <a:rPr lang="en-US" smtClean="0"/>
               <a:pPr/>
-              <a:t>9/29/2026</a:t>
+              <a:t>9/30/2026</a:t>
             </a:fld>
             <a:endParaRPr lang="en-US"/>
           </a:p>
@@ -829,7 +829,7 @@
             <a:fld id="{1D8BD707-D9CF-40AE-B4C6-C98DA3205C09}" type="datetimeFigureOut">
               <a:rPr lang="en-US" smtClean="0"/>
               <a:pPr/>
-              <a:t>9/29/2026</a:t>
+              <a:t>9/30/2026</a:t>
             </a:fld>
             <a:endParaRPr lang="en-US"/>
           </a:p>
@@ -1071,7 +1071,7 @@
             <a:fld id="{1D8BD707-D9CF-40AE-B4C6-C98DA3205C09}" type="datetimeFigureOut">
               <a:rPr lang="en-US" smtClean="0"/>
               <a:pPr/>
-              <a:t>9/29/2026</a:t>
+              <a:t>9/30/2026</a:t>
             </a:fld>
             <a:endParaRPr lang="en-US"/>
           </a:p>
@@ -1353,7 +1353,7 @@
             <a:fld id="{1D8BD707-D9CF-40AE-B4C6-C98DA3205C09}" type="datetimeFigureOut">
               <a:rPr lang="en-US" smtClean="0"/>
               <a:pPr/>
-              <a:t>9/29/2026</a:t>
+              <a:t>9/30/2026</a:t>
             </a:fld>
             <a:endParaRPr lang="en-US"/>
           </a:p>
@@ -1769,7 +1769,7 @@
             <a:fld id="{1D8BD707-D9CF-40AE-B4C6-C98DA3205C09}" type="datetimeFigureOut">
               <a:rPr lang="en-US" smtClean="0"/>
               <a:pPr/>
-              <a:t>9/29/2026</a:t>
+              <a:t>9/30/2026</a:t>
             </a:fld>
             <a:endParaRPr lang="en-US"/>
           </a:p>
@@ -1883,7 +1883,7 @@
             <a:fld id="{1D8BD707-D9CF-40AE-B4C6-C98DA3205C09}" type="datetimeFigureOut">
               <a:rPr lang="en-US" smtClean="0"/>
               <a:pPr/>
-              <a:t>9/29/2026</a:t>
+              <a:t>9/30/2026</a:t>
             </a:fld>
             <a:endParaRPr lang="en-US"/>
           </a:p>
@@ -1975,7 +1975,7 @@
             <a:fld id="{1D8BD707-D9CF-40AE-B4C6-C98DA3205C09}" type="datetimeFigureOut">
               <a:rPr lang="en-US" smtClean="0"/>
               <a:pPr/>
-              <a:t>9/29/2026</a:t>
+              <a:t>9/30/2026</a:t>
             </a:fld>
             <a:endParaRPr lang="en-US"/>
           </a:p>
@@ -2247,7 +2247,7 @@
             <a:fld id="{1D8BD707-D9CF-40AE-B4C6-C98DA3205C09}" type="datetimeFigureOut">
               <a:rPr lang="en-US" smtClean="0"/>
               <a:pPr/>
-              <a:t>9/29/2026</a:t>
+              <a:t>9/30/2026</a:t>
             </a:fld>
             <a:endParaRPr lang="en-US"/>
           </a:p>
@@ -2496,7 +2496,7 @@
             <a:fld id="{1D8BD707-D9CF-40AE-B4C6-C98DA3205C09}" type="datetimeFigureOut">
               <a:rPr lang="en-US" smtClean="0"/>
               <a:pPr/>
-              <a:t>9/29/2026</a:t>
+              <a:t>9/30/2026</a:t>
             </a:fld>
             <a:endParaRPr lang="en-US"/>
           </a:p>
@@ -2704,7 +2704,7 @@
             <a:fld id="{1D8BD707-D9CF-40AE-B4C6-C98DA3205C09}" type="datetimeFigureOut">
               <a:rPr lang="en-US" smtClean="0"/>
               <a:pPr/>
-              <a:t>9/29/2026</a:t>
+              <a:t>9/30/2026</a:t>
             </a:fld>
             <a:endParaRPr lang="en-US"/>
           </a:p>
@@ -3077,59 +3077,13 @@
       </p:grpSpPr>
       <p:sp>
         <p:nvSpPr>
-          <p:cNvPr id="2" name="Freeform 2"/>
-          <p:cNvSpPr/>
-          <p:nvPr/>
-        </p:nvSpPr>
-        <p:spPr>
-          <a:xfrm>
-            <a:off x="8203675" y="466939"/>
-            <a:ext cx="1779422" cy="1550818"/>
-          </a:xfrm>
-          <a:custGeom>
-            <a:avLst/>
-            <a:gdLst/>
-            <a:ahLst/>
-            <a:cxnLst/>
-            <a:rect l="l" t="t" r="r" b="b"/>
-            <a:pathLst>
-              <a:path w="1779422" h="1550818">
-                <a:moveTo>
-                  <a:pt x="0" y="0"/>
-                </a:moveTo>
-                <a:lnTo>
-                  <a:pt x="1779422" y="0"/>
-                </a:lnTo>
-                <a:lnTo>
-                  <a:pt x="1779422" y="1550819"/>
-                </a:lnTo>
-                <a:lnTo>
-                  <a:pt x="0" y="1550819"/>
-                </a:lnTo>
-                <a:lnTo>
-                  <a:pt x="0" y="0"/>
-                </a:lnTo>
-                <a:close/>
-              </a:path>
-            </a:pathLst>
-          </a:custGeom>
-          <a:blipFill>
-            <a:blip r:embed="rId2"/>
-            <a:stretch>
-              <a:fillRect l="-7152" t="-18979" r="-7761" b="-12874"/>
-            </a:stretch>
-          </a:blipFill>
-        </p:spPr>
-      </p:sp>
-      <p:sp>
-        <p:nvSpPr>
           <p:cNvPr id="3" name="TextBox 3"/>
           <p:cNvSpPr txBox="1"/>
           <p:nvPr/>
         </p:nvSpPr>
         <p:spPr>
           <a:xfrm>
-            <a:off x="756000" y="2411348"/>
+            <a:off x="693514" y="3270845"/>
             <a:ext cx="9304971" cy="2564805"/>
           </a:xfrm>
           <a:prstGeom prst="rect">
@@ -3301,7 +3255,31 @@
                 <a:cs typeface="Times New Roman MT Italics"/>
                 <a:sym typeface="Times New Roman MT Italics"/>
               </a:rPr>
-              <a:t> al [Grado] [</a:t>
+              <a:t> al </a:t>
+            </a:r>
+            <a:r>
+              <a:rPr lang="en-US" sz="1723" i="1" spc="113" dirty="0" err="1">
+                <a:solidFill>
+                  <a:srgbClr val="000000"/>
+                </a:solidFill>
+                <a:latin typeface="Times New Roman MT Italics"/>
+                <a:ea typeface="Times New Roman MT Italics"/>
+                <a:cs typeface="Times New Roman MT Italics"/>
+                <a:sym typeface="Times New Roman MT Italics"/>
+              </a:rPr>
+              <a:t>Señor</a:t>
+            </a:r>
+            <a:r>
+              <a:rPr lang="en-US" sz="1723" i="1" spc="113" dirty="0">
+                <a:solidFill>
+                  <a:srgbClr val="000000"/>
+                </a:solidFill>
+                <a:latin typeface="Times New Roman MT Italics"/>
+                <a:ea typeface="Times New Roman MT Italics"/>
+                <a:cs typeface="Times New Roman MT Italics"/>
+                <a:sym typeface="Times New Roman MT Italics"/>
+              </a:rPr>
+              <a:t>/a [</a:t>
             </a:r>
             <a:r>
               <a:rPr lang="en-US" sz="1723" i="1" spc="113" dirty="0" err="1">
@@ -4337,7 +4315,7 @@
         </p:nvSpPr>
         <p:spPr>
           <a:xfrm>
-            <a:off x="2780653" y="1065364"/>
+            <a:off x="2780651" y="2330450"/>
             <a:ext cx="5130695" cy="394547"/>
           </a:xfrm>
           <a:prstGeom prst="rect">
@@ -4356,7 +4334,7 @@
               </a:lnSpc>
             </a:pPr>
             <a:r>
-              <a:rPr lang="en-US" sz="1839" b="1" spc="202">
+              <a:rPr lang="en-US" sz="1839" b="1" spc="202" dirty="0" err="1">
                 <a:solidFill>
                   <a:srgbClr val="000000"/>
                 </a:solidFill>
@@ -4365,7 +4343,43 @@
                 <a:cs typeface="Times New Roman MT Bold"/>
                 <a:sym typeface="Times New Roman MT Bold"/>
               </a:rPr>
-              <a:t>Reconocimiento Arma de Comunicaciones</a:t>
+              <a:t>Reconocimiento</a:t>
+            </a:r>
+            <a:r>
+              <a:rPr lang="en-US" sz="1839" b="1" spc="202" dirty="0">
+                <a:solidFill>
+                  <a:srgbClr val="000000"/>
+                </a:solidFill>
+                <a:latin typeface="Times New Roman MT Bold"/>
+                <a:ea typeface="Times New Roman MT Bold"/>
+                <a:cs typeface="Times New Roman MT Bold"/>
+                <a:sym typeface="Times New Roman MT Bold"/>
+              </a:rPr>
+              <a:t> </a:t>
+            </a:r>
+            <a:r>
+              <a:rPr lang="en-US" sz="1839" b="1" spc="202" dirty="0" err="1">
+                <a:solidFill>
+                  <a:srgbClr val="000000"/>
+                </a:solidFill>
+                <a:latin typeface="Times New Roman MT Bold"/>
+                <a:ea typeface="Times New Roman MT Bold"/>
+                <a:cs typeface="Times New Roman MT Bold"/>
+                <a:sym typeface="Times New Roman MT Bold"/>
+              </a:rPr>
+              <a:t>Arma</a:t>
+            </a:r>
+            <a:r>
+              <a:rPr lang="en-US" sz="1839" b="1" spc="202" dirty="0">
+                <a:solidFill>
+                  <a:srgbClr val="000000"/>
+                </a:solidFill>
+                <a:latin typeface="Times New Roman MT Bold"/>
+                <a:ea typeface="Times New Roman MT Bold"/>
+                <a:cs typeface="Times New Roman MT Bold"/>
+                <a:sym typeface="Times New Roman MT Bold"/>
+              </a:rPr>
+              <a:t> de Comunicaciones</a:t>
             </a:r>
           </a:p>
         </p:txBody>
@@ -4378,7 +4392,7 @@
         </p:nvSpPr>
         <p:spPr>
           <a:xfrm>
-            <a:off x="5973094" y="5126667"/>
+            <a:off x="5956300" y="5835650"/>
             <a:ext cx="4366967" cy="283476"/>
           </a:xfrm>
           <a:prstGeom prst="rect">
@@ -4443,7 +4457,7 @@
         </p:nvSpPr>
         <p:spPr>
           <a:xfrm>
-            <a:off x="897192" y="466939"/>
+            <a:off x="4523216" y="282747"/>
             <a:ext cx="1443662" cy="1705696"/>
           </a:xfrm>
           <a:custGeom>
@@ -4474,7 +4488,7 @@
             </a:pathLst>
           </a:custGeom>
           <a:blipFill>
-            <a:blip r:embed="rId3"/>
+            <a:blip r:embed="rId2"/>
             <a:stretch>
               <a:fillRect b="-198"/>
             </a:stretch>

</xml_diff>

<commit_message>
feat(diploma): update salutation template text
Co-Authored-By: Claude Sonnet 5.5 <noreply@anthropic.com>
</commit_message>
<xml_diff>
--- a/diploma/plantilla_diploma.pptx
+++ b/diploma/plantilla_diploma.pptx
@@ -3111,7 +3111,7 @@
                 <a:cs typeface="Times New Roman MT Italics"/>
                 <a:sym typeface="Times New Roman MT Italics"/>
               </a:rPr>
-              <a:t>La </a:t>
+              <a:t>La Comisión del Arma de Comunicaciones e Informática "Arcángel San Gabriel" tiene el honor de hacer llegar su más distinguido saludo al Señor/a [Nombre y Apellido], con motivo de conmemorarse el 84° Aniversario del Arma de Comunicaciones y el Día del Sistema de Computación de Datos, bajo la sagrada advocación de su Santo Patrono, San Gabriel Arcángel.</a:t>
             </a:r>
             <a:r>
               <a:rPr lang="en-US" sz="1723" i="1" spc="113" dirty="0" err="1">
@@ -3123,19 +3123,19 @@
                 <a:cs typeface="Times New Roman MT Italics"/>
                 <a:sym typeface="Times New Roman MT Italics"/>
               </a:rPr>
-              <a:t>Comisión</a:t>
-            </a:r>
-            <a:r>
-              <a:rPr lang="en-US" sz="1723" i="1" spc="113" dirty="0">
-                <a:solidFill>
-                  <a:srgbClr val="000000"/>
-                </a:solidFill>
-                <a:latin typeface="Times New Roman MT Italics"/>
-                <a:ea typeface="Times New Roman MT Italics"/>
-                <a:cs typeface="Times New Roman MT Italics"/>
-                <a:sym typeface="Times New Roman MT Italics"/>
-              </a:rPr>
-              <a:t> del </a:t>
+              <a:t/>
+            </a:r>
+            <a:r>
+              <a:rPr lang="en-US" sz="1723" i="1" spc="113" dirty="0">
+                <a:solidFill>
+                  <a:srgbClr val="000000"/>
+                </a:solidFill>
+                <a:latin typeface="Times New Roman MT Italics"/>
+                <a:ea typeface="Times New Roman MT Italics"/>
+                <a:cs typeface="Times New Roman MT Italics"/>
+                <a:sym typeface="Times New Roman MT Italics"/>
+              </a:rPr>
+              <a:t/>
             </a:r>
             <a:r>
               <a:rPr lang="en-US" sz="1723" i="1" spc="113" dirty="0" err="1">
@@ -3147,19 +3147,19 @@
                 <a:cs typeface="Times New Roman MT Italics"/>
                 <a:sym typeface="Times New Roman MT Italics"/>
               </a:rPr>
-              <a:t>Arma</a:t>
-            </a:r>
-            <a:r>
-              <a:rPr lang="en-US" sz="1723" i="1" spc="113" dirty="0">
-                <a:solidFill>
-                  <a:srgbClr val="000000"/>
-                </a:solidFill>
-                <a:latin typeface="Times New Roman MT Italics"/>
-                <a:ea typeface="Times New Roman MT Italics"/>
-                <a:cs typeface="Times New Roman MT Italics"/>
-                <a:sym typeface="Times New Roman MT Italics"/>
-              </a:rPr>
-              <a:t> de Comunicaciones e </a:t>
+              <a:t/>
+            </a:r>
+            <a:r>
+              <a:rPr lang="en-US" sz="1723" i="1" spc="113" dirty="0">
+                <a:solidFill>
+                  <a:srgbClr val="000000"/>
+                </a:solidFill>
+                <a:latin typeface="Times New Roman MT Italics"/>
+                <a:ea typeface="Times New Roman MT Italics"/>
+                <a:cs typeface="Times New Roman MT Italics"/>
+                <a:sym typeface="Times New Roman MT Italics"/>
+              </a:rPr>
+              <a:t/>
             </a:r>
             <a:r>
               <a:rPr lang="en-US" sz="1723" i="1" spc="113" dirty="0" err="1">
@@ -3171,19 +3171,19 @@
                 <a:cs typeface="Times New Roman MT Italics"/>
                 <a:sym typeface="Times New Roman MT Italics"/>
               </a:rPr>
-              <a:t>Informática</a:t>
-            </a:r>
-            <a:r>
-              <a:rPr lang="en-US" sz="1723" i="1" spc="113" dirty="0">
-                <a:solidFill>
-                  <a:srgbClr val="000000"/>
-                </a:solidFill>
-                <a:latin typeface="Times New Roman MT Italics"/>
-                <a:ea typeface="Times New Roman MT Italics"/>
-                <a:cs typeface="Times New Roman MT Italics"/>
-                <a:sym typeface="Times New Roman MT Italics"/>
-              </a:rPr>
-              <a:t> "</a:t>
+              <a:t/>
+            </a:r>
+            <a:r>
+              <a:rPr lang="en-US" sz="1723" i="1" spc="113" dirty="0">
+                <a:solidFill>
+                  <a:srgbClr val="000000"/>
+                </a:solidFill>
+                <a:latin typeface="Times New Roman MT Italics"/>
+                <a:ea typeface="Times New Roman MT Italics"/>
+                <a:cs typeface="Times New Roman MT Italics"/>
+                <a:sym typeface="Times New Roman MT Italics"/>
+              </a:rPr>
+              <a:t/>
             </a:r>
             <a:r>
               <a:rPr lang="en-US" sz="1723" i="1" spc="113" dirty="0" err="1">
@@ -3195,19 +3195,19 @@
                 <a:cs typeface="Times New Roman MT Italics"/>
                 <a:sym typeface="Times New Roman MT Italics"/>
               </a:rPr>
-              <a:t>Arcángel</a:t>
-            </a:r>
-            <a:r>
-              <a:rPr lang="en-US" sz="1723" i="1" spc="113" dirty="0">
-                <a:solidFill>
-                  <a:srgbClr val="000000"/>
-                </a:solidFill>
-                <a:latin typeface="Times New Roman MT Italics"/>
-                <a:ea typeface="Times New Roman MT Italics"/>
-                <a:cs typeface="Times New Roman MT Italics"/>
-                <a:sym typeface="Times New Roman MT Italics"/>
-              </a:rPr>
-              <a:t> San Gabriel" </a:t>
+              <a:t/>
+            </a:r>
+            <a:r>
+              <a:rPr lang="en-US" sz="1723" i="1" spc="113" dirty="0">
+                <a:solidFill>
+                  <a:srgbClr val="000000"/>
+                </a:solidFill>
+                <a:latin typeface="Times New Roman MT Italics"/>
+                <a:ea typeface="Times New Roman MT Italics"/>
+                <a:cs typeface="Times New Roman MT Italics"/>
+                <a:sym typeface="Times New Roman MT Italics"/>
+              </a:rPr>
+              <a:t/>
             </a:r>
             <a:r>
               <a:rPr lang="en-US" sz="1723" i="1" spc="113" dirty="0" err="1">
@@ -3219,19 +3219,19 @@
                 <a:cs typeface="Times New Roman MT Italics"/>
                 <a:sym typeface="Times New Roman MT Italics"/>
               </a:rPr>
-              <a:t>tiene</a:t>
-            </a:r>
-            <a:r>
-              <a:rPr lang="en-US" sz="1723" i="1" spc="113" dirty="0">
-                <a:solidFill>
-                  <a:srgbClr val="000000"/>
-                </a:solidFill>
-                <a:latin typeface="Times New Roman MT Italics"/>
-                <a:ea typeface="Times New Roman MT Italics"/>
-                <a:cs typeface="Times New Roman MT Italics"/>
-                <a:sym typeface="Times New Roman MT Italics"/>
-              </a:rPr>
-              <a:t> el honor de </a:t>
+              <a:t/>
+            </a:r>
+            <a:r>
+              <a:rPr lang="en-US" sz="1723" i="1" spc="113" dirty="0">
+                <a:solidFill>
+                  <a:srgbClr val="000000"/>
+                </a:solidFill>
+                <a:latin typeface="Times New Roman MT Italics"/>
+                <a:ea typeface="Times New Roman MT Italics"/>
+                <a:cs typeface="Times New Roman MT Italics"/>
+                <a:sym typeface="Times New Roman MT Italics"/>
+              </a:rPr>
+              <a:t/>
             </a:r>
             <a:r>
               <a:rPr lang="en-US" sz="1723" i="1" spc="113" dirty="0" err="1">
@@ -3243,19 +3243,19 @@
                 <a:cs typeface="Times New Roman MT Italics"/>
                 <a:sym typeface="Times New Roman MT Italics"/>
               </a:rPr>
-              <a:t>saludar</a:t>
-            </a:r>
-            <a:r>
-              <a:rPr lang="en-US" sz="1723" i="1" spc="113" dirty="0">
-                <a:solidFill>
-                  <a:srgbClr val="000000"/>
-                </a:solidFill>
-                <a:latin typeface="Times New Roman MT Italics"/>
-                <a:ea typeface="Times New Roman MT Italics"/>
-                <a:cs typeface="Times New Roman MT Italics"/>
-                <a:sym typeface="Times New Roman MT Italics"/>
-              </a:rPr>
-              <a:t> al </a:t>
+              <a:t/>
+            </a:r>
+            <a:r>
+              <a:rPr lang="en-US" sz="1723" i="1" spc="113" dirty="0">
+                <a:solidFill>
+                  <a:srgbClr val="000000"/>
+                </a:solidFill>
+                <a:latin typeface="Times New Roman MT Italics"/>
+                <a:ea typeface="Times New Roman MT Italics"/>
+                <a:cs typeface="Times New Roman MT Italics"/>
+                <a:sym typeface="Times New Roman MT Italics"/>
+              </a:rPr>
+              <a:t/>
             </a:r>
             <a:r>
               <a:rPr lang="en-US" sz="1723" i="1" spc="113" dirty="0" err="1">
@@ -3267,19 +3267,19 @@
                 <a:cs typeface="Times New Roman MT Italics"/>
                 <a:sym typeface="Times New Roman MT Italics"/>
               </a:rPr>
-              <a:t>Señor</a:t>
-            </a:r>
-            <a:r>
-              <a:rPr lang="en-US" sz="1723" i="1" spc="113" dirty="0">
-                <a:solidFill>
-                  <a:srgbClr val="000000"/>
-                </a:solidFill>
-                <a:latin typeface="Times New Roman MT Italics"/>
-                <a:ea typeface="Times New Roman MT Italics"/>
-                <a:cs typeface="Times New Roman MT Italics"/>
-                <a:sym typeface="Times New Roman MT Italics"/>
-              </a:rPr>
-              <a:t>/a [</a:t>
+              <a:t/>
+            </a:r>
+            <a:r>
+              <a:rPr lang="en-US" sz="1723" i="1" spc="113" dirty="0">
+                <a:solidFill>
+                  <a:srgbClr val="000000"/>
+                </a:solidFill>
+                <a:latin typeface="Times New Roman MT Italics"/>
+                <a:ea typeface="Times New Roman MT Italics"/>
+                <a:cs typeface="Times New Roman MT Italics"/>
+                <a:sym typeface="Times New Roman MT Italics"/>
+              </a:rPr>
+              <a:t/>
             </a:r>
             <a:r>
               <a:rPr lang="en-US" sz="1723" i="1" spc="113" dirty="0" err="1">
@@ -3291,19 +3291,19 @@
                 <a:cs typeface="Times New Roman MT Italics"/>
                 <a:sym typeface="Times New Roman MT Italics"/>
               </a:rPr>
-              <a:t>Nombre</a:t>
-            </a:r>
-            <a:r>
-              <a:rPr lang="en-US" sz="1723" i="1" spc="113" dirty="0">
-                <a:solidFill>
-                  <a:srgbClr val="000000"/>
-                </a:solidFill>
-                <a:latin typeface="Times New Roman MT Italics"/>
-                <a:ea typeface="Times New Roman MT Italics"/>
-                <a:cs typeface="Times New Roman MT Italics"/>
-                <a:sym typeface="Times New Roman MT Italics"/>
-              </a:rPr>
-              <a:t> y </a:t>
+              <a:t/>
+            </a:r>
+            <a:r>
+              <a:rPr lang="en-US" sz="1723" i="1" spc="113" dirty="0">
+                <a:solidFill>
+                  <a:srgbClr val="000000"/>
+                </a:solidFill>
+                <a:latin typeface="Times New Roman MT Italics"/>
+                <a:ea typeface="Times New Roman MT Italics"/>
+                <a:cs typeface="Times New Roman MT Italics"/>
+                <a:sym typeface="Times New Roman MT Italics"/>
+              </a:rPr>
+              <a:t/>
             </a:r>
             <a:r>
               <a:rPr lang="en-US" sz="1723" i="1" spc="113" dirty="0" err="1">
@@ -3315,19 +3315,19 @@
                 <a:cs typeface="Times New Roman MT Italics"/>
                 <a:sym typeface="Times New Roman MT Italics"/>
               </a:rPr>
-              <a:t>Apellido</a:t>
-            </a:r>
-            <a:r>
-              <a:rPr lang="en-US" sz="1723" i="1" spc="113" dirty="0">
-                <a:solidFill>
-                  <a:srgbClr val="000000"/>
-                </a:solidFill>
-                <a:latin typeface="Times New Roman MT Italics"/>
-                <a:ea typeface="Times New Roman MT Italics"/>
-                <a:cs typeface="Times New Roman MT Italics"/>
-                <a:sym typeface="Times New Roman MT Italics"/>
-              </a:rPr>
-              <a:t>], con </a:t>
+              <a:t/>
+            </a:r>
+            <a:r>
+              <a:rPr lang="en-US" sz="1723" i="1" spc="113" dirty="0">
+                <a:solidFill>
+                  <a:srgbClr val="000000"/>
+                </a:solidFill>
+                <a:latin typeface="Times New Roman MT Italics"/>
+                <a:ea typeface="Times New Roman MT Italics"/>
+                <a:cs typeface="Times New Roman MT Italics"/>
+                <a:sym typeface="Times New Roman MT Italics"/>
+              </a:rPr>
+              <a:t/>
             </a:r>
             <a:r>
               <a:rPr lang="en-US" sz="1723" i="1" spc="113" dirty="0" err="1">
@@ -3339,19 +3339,19 @@
                 <a:cs typeface="Times New Roman MT Italics"/>
                 <a:sym typeface="Times New Roman MT Italics"/>
               </a:rPr>
-              <a:t>motivo</a:t>
-            </a:r>
-            <a:r>
-              <a:rPr lang="en-US" sz="1723" i="1" spc="113" dirty="0">
-                <a:solidFill>
-                  <a:srgbClr val="000000"/>
-                </a:solidFill>
-                <a:latin typeface="Times New Roman MT Italics"/>
-                <a:ea typeface="Times New Roman MT Italics"/>
-                <a:cs typeface="Times New Roman MT Italics"/>
-                <a:sym typeface="Times New Roman MT Italics"/>
-              </a:rPr>
-              <a:t> de </a:t>
+              <a:t/>
+            </a:r>
+            <a:r>
+              <a:rPr lang="en-US" sz="1723" i="1" spc="113" dirty="0">
+                <a:solidFill>
+                  <a:srgbClr val="000000"/>
+                </a:solidFill>
+                <a:latin typeface="Times New Roman MT Italics"/>
+                <a:ea typeface="Times New Roman MT Italics"/>
+                <a:cs typeface="Times New Roman MT Italics"/>
+                <a:sym typeface="Times New Roman MT Italics"/>
+              </a:rPr>
+              <a:t/>
             </a:r>
             <a:r>
               <a:rPr lang="en-US" sz="1723" i="1" spc="113" dirty="0" err="1">
@@ -3363,19 +3363,19 @@
                 <a:cs typeface="Times New Roman MT Italics"/>
                 <a:sym typeface="Times New Roman MT Italics"/>
               </a:rPr>
-              <a:t>celebrarse</a:t>
-            </a:r>
-            <a:r>
-              <a:rPr lang="en-US" sz="1723" i="1" spc="113" dirty="0">
-                <a:solidFill>
-                  <a:srgbClr val="000000"/>
-                </a:solidFill>
-                <a:latin typeface="Times New Roman MT Italics"/>
-                <a:ea typeface="Times New Roman MT Italics"/>
-                <a:cs typeface="Times New Roman MT Italics"/>
-                <a:sym typeface="Times New Roman MT Italics"/>
-              </a:rPr>
-              <a:t> el 84° </a:t>
+              <a:t/>
+            </a:r>
+            <a:r>
+              <a:rPr lang="en-US" sz="1723" i="1" spc="113" dirty="0">
+                <a:solidFill>
+                  <a:srgbClr val="000000"/>
+                </a:solidFill>
+                <a:latin typeface="Times New Roman MT Italics"/>
+                <a:ea typeface="Times New Roman MT Italics"/>
+                <a:cs typeface="Times New Roman MT Italics"/>
+                <a:sym typeface="Times New Roman MT Italics"/>
+              </a:rPr>
+              <a:t/>
             </a:r>
             <a:r>
               <a:rPr lang="en-US" sz="1723" i="1" spc="113" dirty="0" err="1">
@@ -3387,19 +3387,19 @@
                 <a:cs typeface="Times New Roman MT Italics"/>
                 <a:sym typeface="Times New Roman MT Italics"/>
               </a:rPr>
-              <a:t>Aniversario</a:t>
-            </a:r>
-            <a:r>
-              <a:rPr lang="en-US" sz="1723" i="1" spc="113" dirty="0">
-                <a:solidFill>
-                  <a:srgbClr val="000000"/>
-                </a:solidFill>
-                <a:latin typeface="Times New Roman MT Italics"/>
-                <a:ea typeface="Times New Roman MT Italics"/>
-                <a:cs typeface="Times New Roman MT Italics"/>
-                <a:sym typeface="Times New Roman MT Italics"/>
-              </a:rPr>
-              <a:t> del </a:t>
+              <a:t/>
+            </a:r>
+            <a:r>
+              <a:rPr lang="en-US" sz="1723" i="1" spc="113" dirty="0">
+                <a:solidFill>
+                  <a:srgbClr val="000000"/>
+                </a:solidFill>
+                <a:latin typeface="Times New Roman MT Italics"/>
+                <a:ea typeface="Times New Roman MT Italics"/>
+                <a:cs typeface="Times New Roman MT Italics"/>
+                <a:sym typeface="Times New Roman MT Italics"/>
+              </a:rPr>
+              <a:t/>
             </a:r>
             <a:r>
               <a:rPr lang="en-US" sz="1723" i="1" spc="113" dirty="0" err="1">
@@ -3411,19 +3411,19 @@
                 <a:cs typeface="Times New Roman MT Italics"/>
                 <a:sym typeface="Times New Roman MT Italics"/>
               </a:rPr>
-              <a:t>Arma</a:t>
-            </a:r>
-            <a:r>
-              <a:rPr lang="en-US" sz="1723" i="1" spc="113" dirty="0">
-                <a:solidFill>
-                  <a:srgbClr val="000000"/>
-                </a:solidFill>
-                <a:latin typeface="Times New Roman MT Italics"/>
-                <a:ea typeface="Times New Roman MT Italics"/>
-                <a:cs typeface="Times New Roman MT Italics"/>
-                <a:sym typeface="Times New Roman MT Italics"/>
-              </a:rPr>
-              <a:t> de Comunicaciones y el Día del Sistema de </a:t>
+              <a:t/>
+            </a:r>
+            <a:r>
+              <a:rPr lang="en-US" sz="1723" i="1" spc="113" dirty="0">
+                <a:solidFill>
+                  <a:srgbClr val="000000"/>
+                </a:solidFill>
+                <a:latin typeface="Times New Roman MT Italics"/>
+                <a:ea typeface="Times New Roman MT Italics"/>
+                <a:cs typeface="Times New Roman MT Italics"/>
+                <a:sym typeface="Times New Roman MT Italics"/>
+              </a:rPr>
+              <a:t/>
             </a:r>
             <a:r>
               <a:rPr lang="en-US" sz="1723" i="1" spc="113" dirty="0" err="1">
@@ -3435,19 +3435,19 @@
                 <a:cs typeface="Times New Roman MT Italics"/>
                 <a:sym typeface="Times New Roman MT Italics"/>
               </a:rPr>
-              <a:t>Computación</a:t>
-            </a:r>
-            <a:r>
-              <a:rPr lang="en-US" sz="1723" i="1" spc="113" dirty="0">
-                <a:solidFill>
-                  <a:srgbClr val="000000"/>
-                </a:solidFill>
-                <a:latin typeface="Times New Roman MT Italics"/>
-                <a:ea typeface="Times New Roman MT Italics"/>
-                <a:cs typeface="Times New Roman MT Italics"/>
-                <a:sym typeface="Times New Roman MT Italics"/>
-              </a:rPr>
-              <a:t> de </a:t>
+              <a:t/>
+            </a:r>
+            <a:r>
+              <a:rPr lang="en-US" sz="1723" i="1" spc="113" dirty="0">
+                <a:solidFill>
+                  <a:srgbClr val="000000"/>
+                </a:solidFill>
+                <a:latin typeface="Times New Roman MT Italics"/>
+                <a:ea typeface="Times New Roman MT Italics"/>
+                <a:cs typeface="Times New Roman MT Italics"/>
+                <a:sym typeface="Times New Roman MT Italics"/>
+              </a:rPr>
+              <a:t/>
             </a:r>
             <a:r>
               <a:rPr lang="en-US" sz="1723" i="1" spc="113" dirty="0" err="1">
@@ -3459,19 +3459,19 @@
                 <a:cs typeface="Times New Roman MT Italics"/>
                 <a:sym typeface="Times New Roman MT Italics"/>
               </a:rPr>
-              <a:t>Datos</a:t>
-            </a:r>
-            <a:r>
-              <a:rPr lang="en-US" sz="1723" i="1" spc="113" dirty="0">
-                <a:solidFill>
-                  <a:srgbClr val="000000"/>
-                </a:solidFill>
-                <a:latin typeface="Times New Roman MT Italics"/>
-                <a:ea typeface="Times New Roman MT Italics"/>
-                <a:cs typeface="Times New Roman MT Italics"/>
-                <a:sym typeface="Times New Roman MT Italics"/>
-              </a:rPr>
-              <a:t>, bajo la </a:t>
+              <a:t/>
+            </a:r>
+            <a:r>
+              <a:rPr lang="en-US" sz="1723" i="1" spc="113" dirty="0">
+                <a:solidFill>
+                  <a:srgbClr val="000000"/>
+                </a:solidFill>
+                <a:latin typeface="Times New Roman MT Italics"/>
+                <a:ea typeface="Times New Roman MT Italics"/>
+                <a:cs typeface="Times New Roman MT Italics"/>
+                <a:sym typeface="Times New Roman MT Italics"/>
+              </a:rPr>
+              <a:t/>
             </a:r>
             <a:r>
               <a:rPr lang="en-US" sz="1723" i="1" spc="113" dirty="0" err="1">
@@ -3483,19 +3483,19 @@
                 <a:cs typeface="Times New Roman MT Italics"/>
                 <a:sym typeface="Times New Roman MT Italics"/>
               </a:rPr>
-              <a:t>advocación</a:t>
-            </a:r>
-            <a:r>
-              <a:rPr lang="en-US" sz="1723" i="1" spc="113" dirty="0">
-                <a:solidFill>
-                  <a:srgbClr val="000000"/>
-                </a:solidFill>
-                <a:latin typeface="Times New Roman MT Italics"/>
-                <a:ea typeface="Times New Roman MT Italics"/>
-                <a:cs typeface="Times New Roman MT Italics"/>
-                <a:sym typeface="Times New Roman MT Italics"/>
-              </a:rPr>
-              <a:t> de </a:t>
+              <a:t/>
+            </a:r>
+            <a:r>
+              <a:rPr lang="en-US" sz="1723" i="1" spc="113" dirty="0">
+                <a:solidFill>
+                  <a:srgbClr val="000000"/>
+                </a:solidFill>
+                <a:latin typeface="Times New Roman MT Italics"/>
+                <a:ea typeface="Times New Roman MT Italics"/>
+                <a:cs typeface="Times New Roman MT Italics"/>
+                <a:sym typeface="Times New Roman MT Italics"/>
+              </a:rPr>
+              <a:t/>
             </a:r>
             <a:r>
               <a:rPr lang="en-US" sz="1723" i="1" spc="113" dirty="0" err="1">
@@ -3507,19 +3507,19 @@
                 <a:cs typeface="Times New Roman MT Italics"/>
                 <a:sym typeface="Times New Roman MT Italics"/>
               </a:rPr>
-              <a:t>su</a:t>
-            </a:r>
-            <a:r>
-              <a:rPr lang="en-US" sz="1723" i="1" spc="113" dirty="0">
-                <a:solidFill>
-                  <a:srgbClr val="000000"/>
-                </a:solidFill>
-                <a:latin typeface="Times New Roman MT Italics"/>
-                <a:ea typeface="Times New Roman MT Italics"/>
-                <a:cs typeface="Times New Roman MT Italics"/>
-                <a:sym typeface="Times New Roman MT Italics"/>
-              </a:rPr>
-              <a:t> Santo </a:t>
+              <a:t/>
+            </a:r>
+            <a:r>
+              <a:rPr lang="en-US" sz="1723" i="1" spc="113" dirty="0">
+                <a:solidFill>
+                  <a:srgbClr val="000000"/>
+                </a:solidFill>
+                <a:latin typeface="Times New Roman MT Italics"/>
+                <a:ea typeface="Times New Roman MT Italics"/>
+                <a:cs typeface="Times New Roman MT Italics"/>
+                <a:sym typeface="Times New Roman MT Italics"/>
+              </a:rPr>
+              <a:t/>
             </a:r>
             <a:r>
               <a:rPr lang="en-US" sz="1723" i="1" spc="113" dirty="0" err="1">
@@ -3531,19 +3531,19 @@
                 <a:cs typeface="Times New Roman MT Italics"/>
                 <a:sym typeface="Times New Roman MT Italics"/>
               </a:rPr>
-              <a:t>Patrono</a:t>
-            </a:r>
-            <a:r>
-              <a:rPr lang="en-US" sz="1723" i="1" spc="113" dirty="0">
-                <a:solidFill>
-                  <a:srgbClr val="000000"/>
-                </a:solidFill>
-                <a:latin typeface="Times New Roman MT Italics"/>
-                <a:ea typeface="Times New Roman MT Italics"/>
-                <a:cs typeface="Times New Roman MT Italics"/>
-                <a:sym typeface="Times New Roman MT Italics"/>
-              </a:rPr>
-              <a:t>, San Gabriel </a:t>
+              <a:t/>
+            </a:r>
+            <a:r>
+              <a:rPr lang="en-US" sz="1723" i="1" spc="113" dirty="0">
+                <a:solidFill>
+                  <a:srgbClr val="000000"/>
+                </a:solidFill>
+                <a:latin typeface="Times New Roman MT Italics"/>
+                <a:ea typeface="Times New Roman MT Italics"/>
+                <a:cs typeface="Times New Roman MT Italics"/>
+                <a:sym typeface="Times New Roman MT Italics"/>
+              </a:rPr>
+              <a:t/>
             </a:r>
             <a:r>
               <a:rPr lang="en-US" sz="1723" i="1" spc="113" dirty="0" err="1">
@@ -3555,19 +3555,19 @@
                 <a:cs typeface="Times New Roman MT Italics"/>
                 <a:sym typeface="Times New Roman MT Italics"/>
               </a:rPr>
-              <a:t>Arcángel</a:t>
-            </a:r>
-            <a:r>
-              <a:rPr lang="en-US" sz="1723" i="1" spc="113" dirty="0">
-                <a:solidFill>
-                  <a:srgbClr val="000000"/>
-                </a:solidFill>
-                <a:latin typeface="Times New Roman MT Italics"/>
-                <a:ea typeface="Times New Roman MT Italics"/>
-                <a:cs typeface="Times New Roman MT Italics"/>
-                <a:sym typeface="Times New Roman MT Italics"/>
-              </a:rPr>
-              <a:t>.</a:t>
+              <a:t/>
+            </a:r>
+            <a:r>
+              <a:rPr lang="en-US" sz="1723" i="1" spc="113" dirty="0">
+                <a:solidFill>
+                  <a:srgbClr val="000000"/>
+                </a:solidFill>
+                <a:latin typeface="Times New Roman MT Italics"/>
+                <a:ea typeface="Times New Roman MT Italics"/>
+                <a:cs typeface="Times New Roman MT Italics"/>
+                <a:sym typeface="Times New Roman MT Italics"/>
+              </a:rPr>
+              <a:t/>
             </a:r>
           </a:p>
           <a:p>
@@ -3602,19 +3602,19 @@
                 <a:cs typeface="Times New Roman MT Italics"/>
                 <a:sym typeface="Times New Roman MT Italics"/>
               </a:rPr>
-              <a:t>Asimismo</a:t>
-            </a:r>
-            <a:r>
-              <a:rPr lang="en-US" sz="1723" i="1" spc="113" dirty="0">
-                <a:solidFill>
-                  <a:srgbClr val="000000"/>
-                </a:solidFill>
-                <a:latin typeface="Times New Roman MT Italics"/>
-                <a:ea typeface="Times New Roman MT Italics"/>
-                <a:cs typeface="Times New Roman MT Italics"/>
-                <a:sym typeface="Times New Roman MT Italics"/>
-              </a:rPr>
-              <a:t>, le </a:t>
+              <a:t>Asimismo, le expresa su más sincero agradecimiento por su honrosa presencia en la Ceremonia Central, llevada a cabo el 2 de octubre de 2026 en la Guarnición Ejército "Córdoba". Su participación ha otorgado un especial realce a este acto, posible gracias al valioso acompañamiento de quienes, como usted, enaltecen la historia y el espíritu de nuestra Arma.</a:t>
+            </a:r>
+            <a:r>
+              <a:rPr lang="en-US" sz="1723" i="1" spc="113" dirty="0">
+                <a:solidFill>
+                  <a:srgbClr val="000000"/>
+                </a:solidFill>
+                <a:latin typeface="Times New Roman MT Italics"/>
+                <a:ea typeface="Times New Roman MT Italics"/>
+                <a:cs typeface="Times New Roman MT Italics"/>
+                <a:sym typeface="Times New Roman MT Italics"/>
+              </a:rPr>
+              <a:t/>
             </a:r>
             <a:r>
               <a:rPr lang="en-US" sz="1723" i="1" spc="113" dirty="0" err="1">
@@ -3626,19 +3626,19 @@
                 <a:cs typeface="Times New Roman MT Italics"/>
                 <a:sym typeface="Times New Roman MT Italics"/>
               </a:rPr>
-              <a:t>expresa</a:t>
-            </a:r>
-            <a:r>
-              <a:rPr lang="en-US" sz="1723" i="1" spc="113" dirty="0">
-                <a:solidFill>
-                  <a:srgbClr val="000000"/>
-                </a:solidFill>
-                <a:latin typeface="Times New Roman MT Italics"/>
-                <a:ea typeface="Times New Roman MT Italics"/>
-                <a:cs typeface="Times New Roman MT Italics"/>
-                <a:sym typeface="Times New Roman MT Italics"/>
-              </a:rPr>
-              <a:t> </a:t>
+              <a:t/>
+            </a:r>
+            <a:r>
+              <a:rPr lang="en-US" sz="1723" i="1" spc="113" dirty="0">
+                <a:solidFill>
+                  <a:srgbClr val="000000"/>
+                </a:solidFill>
+                <a:latin typeface="Times New Roman MT Italics"/>
+                <a:ea typeface="Times New Roman MT Italics"/>
+                <a:cs typeface="Times New Roman MT Italics"/>
+                <a:sym typeface="Times New Roman MT Italics"/>
+              </a:rPr>
+              <a:t/>
             </a:r>
             <a:r>
               <a:rPr lang="en-US" sz="1723" i="1" spc="113" dirty="0" err="1">
@@ -3650,19 +3650,19 @@
                 <a:cs typeface="Times New Roman MT Italics"/>
                 <a:sym typeface="Times New Roman MT Italics"/>
               </a:rPr>
-              <a:t>su</a:t>
-            </a:r>
-            <a:r>
-              <a:rPr lang="en-US" sz="1723" i="1" spc="113" dirty="0">
-                <a:solidFill>
-                  <a:srgbClr val="000000"/>
-                </a:solidFill>
-                <a:latin typeface="Times New Roman MT Italics"/>
-                <a:ea typeface="Times New Roman MT Italics"/>
-                <a:cs typeface="Times New Roman MT Italics"/>
-                <a:sym typeface="Times New Roman MT Italics"/>
-              </a:rPr>
-              <a:t> </a:t>
+              <a:t/>
+            </a:r>
+            <a:r>
+              <a:rPr lang="en-US" sz="1723" i="1" spc="113" dirty="0">
+                <a:solidFill>
+                  <a:srgbClr val="000000"/>
+                </a:solidFill>
+                <a:latin typeface="Times New Roman MT Italics"/>
+                <a:ea typeface="Times New Roman MT Italics"/>
+                <a:cs typeface="Times New Roman MT Italics"/>
+                <a:sym typeface="Times New Roman MT Italics"/>
+              </a:rPr>
+              <a:t/>
             </a:r>
             <a:r>
               <a:rPr lang="en-US" sz="1723" i="1" spc="113" dirty="0" err="1">
@@ -3674,19 +3674,19 @@
                 <a:cs typeface="Times New Roman MT Italics"/>
                 <a:sym typeface="Times New Roman MT Italics"/>
               </a:rPr>
-              <a:t>sincero</a:t>
-            </a:r>
-            <a:r>
-              <a:rPr lang="en-US" sz="1723" i="1" spc="113" dirty="0">
-                <a:solidFill>
-                  <a:srgbClr val="000000"/>
-                </a:solidFill>
-                <a:latin typeface="Times New Roman MT Italics"/>
-                <a:ea typeface="Times New Roman MT Italics"/>
-                <a:cs typeface="Times New Roman MT Italics"/>
-                <a:sym typeface="Times New Roman MT Italics"/>
-              </a:rPr>
-              <a:t> </a:t>
+              <a:t/>
+            </a:r>
+            <a:r>
+              <a:rPr lang="en-US" sz="1723" i="1" spc="113" dirty="0">
+                <a:solidFill>
+                  <a:srgbClr val="000000"/>
+                </a:solidFill>
+                <a:latin typeface="Times New Roman MT Italics"/>
+                <a:ea typeface="Times New Roman MT Italics"/>
+                <a:cs typeface="Times New Roman MT Italics"/>
+                <a:sym typeface="Times New Roman MT Italics"/>
+              </a:rPr>
+              <a:t/>
             </a:r>
             <a:r>
               <a:rPr lang="en-US" sz="1723" i="1" spc="113" dirty="0" err="1">
@@ -3698,19 +3698,19 @@
                 <a:cs typeface="Times New Roman MT Italics"/>
                 <a:sym typeface="Times New Roman MT Italics"/>
               </a:rPr>
-              <a:t>agradecimiento</a:t>
-            </a:r>
-            <a:r>
-              <a:rPr lang="en-US" sz="1723" i="1" spc="113" dirty="0">
-                <a:solidFill>
-                  <a:srgbClr val="000000"/>
-                </a:solidFill>
-                <a:latin typeface="Times New Roman MT Italics"/>
-                <a:ea typeface="Times New Roman MT Italics"/>
-                <a:cs typeface="Times New Roman MT Italics"/>
-                <a:sym typeface="Times New Roman MT Italics"/>
-              </a:rPr>
-              <a:t> por </a:t>
+              <a:t/>
+            </a:r>
+            <a:r>
+              <a:rPr lang="en-US" sz="1723" i="1" spc="113" dirty="0">
+                <a:solidFill>
+                  <a:srgbClr val="000000"/>
+                </a:solidFill>
+                <a:latin typeface="Times New Roman MT Italics"/>
+                <a:ea typeface="Times New Roman MT Italics"/>
+                <a:cs typeface="Times New Roman MT Italics"/>
+                <a:sym typeface="Times New Roman MT Italics"/>
+              </a:rPr>
+              <a:t/>
             </a:r>
             <a:r>
               <a:rPr lang="en-US" sz="1723" i="1" spc="113" dirty="0" err="1">
@@ -3722,19 +3722,19 @@
                 <a:cs typeface="Times New Roman MT Italics"/>
                 <a:sym typeface="Times New Roman MT Italics"/>
               </a:rPr>
-              <a:t>su</a:t>
-            </a:r>
-            <a:r>
-              <a:rPr lang="en-US" sz="1723" i="1" spc="113" dirty="0">
-                <a:solidFill>
-                  <a:srgbClr val="000000"/>
-                </a:solidFill>
-                <a:latin typeface="Times New Roman MT Italics"/>
-                <a:ea typeface="Times New Roman MT Italics"/>
-                <a:cs typeface="Times New Roman MT Italics"/>
-                <a:sym typeface="Times New Roman MT Italics"/>
-              </a:rPr>
-              <a:t> </a:t>
+              <a:t/>
+            </a:r>
+            <a:r>
+              <a:rPr lang="en-US" sz="1723" i="1" spc="113" dirty="0">
+                <a:solidFill>
+                  <a:srgbClr val="000000"/>
+                </a:solidFill>
+                <a:latin typeface="Times New Roman MT Italics"/>
+                <a:ea typeface="Times New Roman MT Italics"/>
+                <a:cs typeface="Times New Roman MT Italics"/>
+                <a:sym typeface="Times New Roman MT Italics"/>
+              </a:rPr>
+              <a:t/>
             </a:r>
             <a:r>
               <a:rPr lang="en-US" sz="1723" i="1" spc="113" dirty="0" err="1">
@@ -3746,19 +3746,19 @@
                 <a:cs typeface="Times New Roman MT Italics"/>
                 <a:sym typeface="Times New Roman MT Italics"/>
               </a:rPr>
-              <a:t>presencia</a:t>
-            </a:r>
-            <a:r>
-              <a:rPr lang="en-US" sz="1723" i="1" spc="113" dirty="0">
-                <a:solidFill>
-                  <a:srgbClr val="000000"/>
-                </a:solidFill>
-                <a:latin typeface="Times New Roman MT Italics"/>
-                <a:ea typeface="Times New Roman MT Italics"/>
-                <a:cs typeface="Times New Roman MT Italics"/>
-                <a:sym typeface="Times New Roman MT Italics"/>
-              </a:rPr>
-              <a:t> </a:t>
+              <a:t/>
+            </a:r>
+            <a:r>
+              <a:rPr lang="en-US" sz="1723" i="1" spc="113" dirty="0">
+                <a:solidFill>
+                  <a:srgbClr val="000000"/>
+                </a:solidFill>
+                <a:latin typeface="Times New Roman MT Italics"/>
+                <a:ea typeface="Times New Roman MT Italics"/>
+                <a:cs typeface="Times New Roman MT Italics"/>
+                <a:sym typeface="Times New Roman MT Italics"/>
+              </a:rPr>
+              <a:t/>
             </a:r>
             <a:r>
               <a:rPr lang="en-US" sz="1723" i="1" spc="113" dirty="0" err="1">
@@ -3770,19 +3770,19 @@
                 <a:cs typeface="Times New Roman MT Italics"/>
                 <a:sym typeface="Times New Roman MT Italics"/>
               </a:rPr>
-              <a:t>en</a:t>
-            </a:r>
-            <a:r>
-              <a:rPr lang="en-US" sz="1723" i="1" spc="113" dirty="0">
-                <a:solidFill>
-                  <a:srgbClr val="000000"/>
-                </a:solidFill>
-                <a:latin typeface="Times New Roman MT Italics"/>
-                <a:ea typeface="Times New Roman MT Italics"/>
-                <a:cs typeface="Times New Roman MT Italics"/>
-                <a:sym typeface="Times New Roman MT Italics"/>
-              </a:rPr>
-              <a:t> la </a:t>
+              <a:t/>
+            </a:r>
+            <a:r>
+              <a:rPr lang="en-US" sz="1723" i="1" spc="113" dirty="0">
+                <a:solidFill>
+                  <a:srgbClr val="000000"/>
+                </a:solidFill>
+                <a:latin typeface="Times New Roman MT Italics"/>
+                <a:ea typeface="Times New Roman MT Italics"/>
+                <a:cs typeface="Times New Roman MT Italics"/>
+                <a:sym typeface="Times New Roman MT Italics"/>
+              </a:rPr>
+              <a:t/>
             </a:r>
             <a:r>
               <a:rPr lang="en-US" sz="1723" i="1" spc="113" dirty="0" err="1">
@@ -3794,19 +3794,19 @@
                 <a:cs typeface="Times New Roman MT Italics"/>
                 <a:sym typeface="Times New Roman MT Italics"/>
               </a:rPr>
-              <a:t>Ceremonia</a:t>
-            </a:r>
-            <a:r>
-              <a:rPr lang="en-US" sz="1723" i="1" spc="113" dirty="0">
-                <a:solidFill>
-                  <a:srgbClr val="000000"/>
-                </a:solidFill>
-                <a:latin typeface="Times New Roman MT Italics"/>
-                <a:ea typeface="Times New Roman MT Italics"/>
-                <a:cs typeface="Times New Roman MT Italics"/>
-                <a:sym typeface="Times New Roman MT Italics"/>
-              </a:rPr>
-              <a:t> Central, </a:t>
+              <a:t/>
+            </a:r>
+            <a:r>
+              <a:rPr lang="en-US" sz="1723" i="1" spc="113" dirty="0">
+                <a:solidFill>
+                  <a:srgbClr val="000000"/>
+                </a:solidFill>
+                <a:latin typeface="Times New Roman MT Italics"/>
+                <a:ea typeface="Times New Roman MT Italics"/>
+                <a:cs typeface="Times New Roman MT Italics"/>
+                <a:sym typeface="Times New Roman MT Italics"/>
+              </a:rPr>
+              <a:t/>
             </a:r>
             <a:r>
               <a:rPr lang="en-US" sz="1723" i="1" spc="113" dirty="0" err="1">
@@ -3818,19 +3818,19 @@
                 <a:cs typeface="Times New Roman MT Italics"/>
                 <a:sym typeface="Times New Roman MT Italics"/>
               </a:rPr>
-              <a:t>realizada</a:t>
-            </a:r>
-            <a:r>
-              <a:rPr lang="en-US" sz="1723" i="1" spc="113" dirty="0">
-                <a:solidFill>
-                  <a:srgbClr val="000000"/>
-                </a:solidFill>
-                <a:latin typeface="Times New Roman MT Italics"/>
-                <a:ea typeface="Times New Roman MT Italics"/>
-                <a:cs typeface="Times New Roman MT Italics"/>
-                <a:sym typeface="Times New Roman MT Italics"/>
-              </a:rPr>
-              <a:t> el 2 de </a:t>
+              <a:t/>
+            </a:r>
+            <a:r>
+              <a:rPr lang="en-US" sz="1723" i="1" spc="113" dirty="0">
+                <a:solidFill>
+                  <a:srgbClr val="000000"/>
+                </a:solidFill>
+                <a:latin typeface="Times New Roman MT Italics"/>
+                <a:ea typeface="Times New Roman MT Italics"/>
+                <a:cs typeface="Times New Roman MT Italics"/>
+                <a:sym typeface="Times New Roman MT Italics"/>
+              </a:rPr>
+              <a:t/>
             </a:r>
             <a:r>
               <a:rPr lang="en-US" sz="1723" i="1" spc="113" dirty="0" err="1">
@@ -3842,19 +3842,19 @@
                 <a:cs typeface="Times New Roman MT Italics"/>
                 <a:sym typeface="Times New Roman MT Italics"/>
               </a:rPr>
-              <a:t>octubre</a:t>
-            </a:r>
-            <a:r>
-              <a:rPr lang="en-US" sz="1723" i="1" spc="113" dirty="0">
-                <a:solidFill>
-                  <a:srgbClr val="000000"/>
-                </a:solidFill>
-                <a:latin typeface="Times New Roman MT Italics"/>
-                <a:ea typeface="Times New Roman MT Italics"/>
-                <a:cs typeface="Times New Roman MT Italics"/>
-                <a:sym typeface="Times New Roman MT Italics"/>
-              </a:rPr>
-              <a:t> de 2026 </a:t>
+              <a:t/>
+            </a:r>
+            <a:r>
+              <a:rPr lang="en-US" sz="1723" i="1" spc="113" dirty="0">
+                <a:solidFill>
+                  <a:srgbClr val="000000"/>
+                </a:solidFill>
+                <a:latin typeface="Times New Roman MT Italics"/>
+                <a:ea typeface="Times New Roman MT Italics"/>
+                <a:cs typeface="Times New Roman MT Italics"/>
+                <a:sym typeface="Times New Roman MT Italics"/>
+              </a:rPr>
+              <a:t/>
             </a:r>
             <a:r>
               <a:rPr lang="en-US" sz="1723" i="1" spc="113" dirty="0" err="1">
@@ -3866,19 +3866,19 @@
                 <a:cs typeface="Times New Roman MT Italics"/>
                 <a:sym typeface="Times New Roman MT Italics"/>
               </a:rPr>
-              <a:t>en</a:t>
-            </a:r>
-            <a:r>
-              <a:rPr lang="en-US" sz="1723" i="1" spc="113" dirty="0">
-                <a:solidFill>
-                  <a:srgbClr val="000000"/>
-                </a:solidFill>
-                <a:latin typeface="Times New Roman MT Italics"/>
-                <a:ea typeface="Times New Roman MT Italics"/>
-                <a:cs typeface="Times New Roman MT Italics"/>
-                <a:sym typeface="Times New Roman MT Italics"/>
-              </a:rPr>
-              <a:t> la </a:t>
+              <a:t/>
+            </a:r>
+            <a:r>
+              <a:rPr lang="en-US" sz="1723" i="1" spc="113" dirty="0">
+                <a:solidFill>
+                  <a:srgbClr val="000000"/>
+                </a:solidFill>
+                <a:latin typeface="Times New Roman MT Italics"/>
+                <a:ea typeface="Times New Roman MT Italics"/>
+                <a:cs typeface="Times New Roman MT Italics"/>
+                <a:sym typeface="Times New Roman MT Italics"/>
+              </a:rPr>
+              <a:t/>
             </a:r>
             <a:r>
               <a:rPr lang="en-US" sz="1723" i="1" spc="113" dirty="0" err="1">
@@ -3890,19 +3890,19 @@
                 <a:cs typeface="Times New Roman MT Italics"/>
                 <a:sym typeface="Times New Roman MT Italics"/>
               </a:rPr>
-              <a:t>Guarnición</a:t>
-            </a:r>
-            <a:r>
-              <a:rPr lang="en-US" sz="1723" i="1" spc="113" dirty="0">
-                <a:solidFill>
-                  <a:srgbClr val="000000"/>
-                </a:solidFill>
-                <a:latin typeface="Times New Roman MT Italics"/>
-                <a:ea typeface="Times New Roman MT Italics"/>
-                <a:cs typeface="Times New Roman MT Italics"/>
-                <a:sym typeface="Times New Roman MT Italics"/>
-              </a:rPr>
-              <a:t> </a:t>
+              <a:t/>
+            </a:r>
+            <a:r>
+              <a:rPr lang="en-US" sz="1723" i="1" spc="113" dirty="0">
+                <a:solidFill>
+                  <a:srgbClr val="000000"/>
+                </a:solidFill>
+                <a:latin typeface="Times New Roman MT Italics"/>
+                <a:ea typeface="Times New Roman MT Italics"/>
+                <a:cs typeface="Times New Roman MT Italics"/>
+                <a:sym typeface="Times New Roman MT Italics"/>
+              </a:rPr>
+              <a:t/>
             </a:r>
             <a:r>
               <a:rPr lang="en-US" sz="1723" i="1" spc="113" dirty="0" err="1">
@@ -3914,19 +3914,19 @@
                 <a:cs typeface="Times New Roman MT Italics"/>
                 <a:sym typeface="Times New Roman MT Italics"/>
               </a:rPr>
-              <a:t>Ejército</a:t>
-            </a:r>
-            <a:r>
-              <a:rPr lang="en-US" sz="1723" i="1" spc="113" dirty="0">
-                <a:solidFill>
-                  <a:srgbClr val="000000"/>
-                </a:solidFill>
-                <a:latin typeface="Times New Roman MT Italics"/>
-                <a:ea typeface="Times New Roman MT Italics"/>
-                <a:cs typeface="Times New Roman MT Italics"/>
-                <a:sym typeface="Times New Roman MT Italics"/>
-              </a:rPr>
-              <a:t> "Córdoba", </a:t>
+              <a:t/>
+            </a:r>
+            <a:r>
+              <a:rPr lang="en-US" sz="1723" i="1" spc="113" dirty="0">
+                <a:solidFill>
+                  <a:srgbClr val="000000"/>
+                </a:solidFill>
+                <a:latin typeface="Times New Roman MT Italics"/>
+                <a:ea typeface="Times New Roman MT Italics"/>
+                <a:cs typeface="Times New Roman MT Italics"/>
+                <a:sym typeface="Times New Roman MT Italics"/>
+              </a:rPr>
+              <a:t/>
             </a:r>
             <a:r>
               <a:rPr lang="en-US" sz="1723" i="1" spc="113" dirty="0" err="1">
@@ -3938,19 +3938,19 @@
                 <a:cs typeface="Times New Roman MT Italics"/>
                 <a:sym typeface="Times New Roman MT Italics"/>
               </a:rPr>
-              <a:t>cuyo</a:t>
-            </a:r>
-            <a:r>
-              <a:rPr lang="en-US" sz="1723" i="1" spc="113" dirty="0">
-                <a:solidFill>
-                  <a:srgbClr val="000000"/>
-                </a:solidFill>
-                <a:latin typeface="Times New Roman MT Italics"/>
-                <a:ea typeface="Times New Roman MT Italics"/>
-                <a:cs typeface="Times New Roman MT Italics"/>
-                <a:sym typeface="Times New Roman MT Italics"/>
-              </a:rPr>
-              <a:t> </a:t>
+              <a:t/>
+            </a:r>
+            <a:r>
+              <a:rPr lang="en-US" sz="1723" i="1" spc="113" dirty="0">
+                <a:solidFill>
+                  <a:srgbClr val="000000"/>
+                </a:solidFill>
+                <a:latin typeface="Times New Roman MT Italics"/>
+                <a:ea typeface="Times New Roman MT Italics"/>
+                <a:cs typeface="Times New Roman MT Italics"/>
+                <a:sym typeface="Times New Roman MT Italics"/>
+              </a:rPr>
+              <a:t/>
             </a:r>
             <a:r>
               <a:rPr lang="en-US" sz="1723" i="1" spc="113" dirty="0" err="1">
@@ -3962,19 +3962,19 @@
                 <a:cs typeface="Times New Roman MT Italics"/>
                 <a:sym typeface="Times New Roman MT Italics"/>
               </a:rPr>
-              <a:t>realce</a:t>
-            </a:r>
-            <a:r>
-              <a:rPr lang="en-US" sz="1723" i="1" spc="113" dirty="0">
-                <a:solidFill>
-                  <a:srgbClr val="000000"/>
-                </a:solidFill>
-                <a:latin typeface="Times New Roman MT Italics"/>
-                <a:ea typeface="Times New Roman MT Italics"/>
-                <a:cs typeface="Times New Roman MT Italics"/>
-                <a:sym typeface="Times New Roman MT Italics"/>
-              </a:rPr>
-              <a:t> </a:t>
+              <a:t/>
+            </a:r>
+            <a:r>
+              <a:rPr lang="en-US" sz="1723" i="1" spc="113" dirty="0">
+                <a:solidFill>
+                  <a:srgbClr val="000000"/>
+                </a:solidFill>
+                <a:latin typeface="Times New Roman MT Italics"/>
+                <a:ea typeface="Times New Roman MT Italics"/>
+                <a:cs typeface="Times New Roman MT Italics"/>
+                <a:sym typeface="Times New Roman MT Italics"/>
+              </a:rPr>
+              <a:t/>
             </a:r>
             <a:r>
               <a:rPr lang="en-US" sz="1723" i="1" spc="113" dirty="0" err="1">
@@ -3986,19 +3986,19 @@
                 <a:cs typeface="Times New Roman MT Italics"/>
                 <a:sym typeface="Times New Roman MT Italics"/>
               </a:rPr>
-              <a:t>fue</a:t>
-            </a:r>
-            <a:r>
-              <a:rPr lang="en-US" sz="1723" i="1" spc="113" dirty="0">
-                <a:solidFill>
-                  <a:srgbClr val="000000"/>
-                </a:solidFill>
-                <a:latin typeface="Times New Roman MT Italics"/>
-                <a:ea typeface="Times New Roman MT Italics"/>
-                <a:cs typeface="Times New Roman MT Italics"/>
-                <a:sym typeface="Times New Roman MT Italics"/>
-              </a:rPr>
-              <a:t> </a:t>
+              <a:t/>
+            </a:r>
+            <a:r>
+              <a:rPr lang="en-US" sz="1723" i="1" spc="113" dirty="0">
+                <a:solidFill>
+                  <a:srgbClr val="000000"/>
+                </a:solidFill>
+                <a:latin typeface="Times New Roman MT Italics"/>
+                <a:ea typeface="Times New Roman MT Italics"/>
+                <a:cs typeface="Times New Roman MT Italics"/>
+                <a:sym typeface="Times New Roman MT Italics"/>
+              </a:rPr>
+              <a:t/>
             </a:r>
             <a:r>
               <a:rPr lang="en-US" sz="1723" i="1" spc="113" dirty="0" err="1">
@@ -4010,19 +4010,19 @@
                 <a:cs typeface="Times New Roman MT Italics"/>
                 <a:sym typeface="Times New Roman MT Italics"/>
               </a:rPr>
-              <a:t>posible</a:t>
-            </a:r>
-            <a:r>
-              <a:rPr lang="en-US" sz="1723" i="1" spc="113" dirty="0">
-                <a:solidFill>
-                  <a:srgbClr val="000000"/>
-                </a:solidFill>
-                <a:latin typeface="Times New Roman MT Italics"/>
-                <a:ea typeface="Times New Roman MT Italics"/>
-                <a:cs typeface="Times New Roman MT Italics"/>
-                <a:sym typeface="Times New Roman MT Italics"/>
-              </a:rPr>
-              <a:t> gracias al </a:t>
+              <a:t/>
+            </a:r>
+            <a:r>
+              <a:rPr lang="en-US" sz="1723" i="1" spc="113" dirty="0">
+                <a:solidFill>
+                  <a:srgbClr val="000000"/>
+                </a:solidFill>
+                <a:latin typeface="Times New Roman MT Italics"/>
+                <a:ea typeface="Times New Roman MT Italics"/>
+                <a:cs typeface="Times New Roman MT Italics"/>
+                <a:sym typeface="Times New Roman MT Italics"/>
+              </a:rPr>
+              <a:t/>
             </a:r>
             <a:r>
               <a:rPr lang="en-US" sz="1723" i="1" spc="113" dirty="0" err="1">
@@ -4034,19 +4034,19 @@
                 <a:cs typeface="Times New Roman MT Italics"/>
                 <a:sym typeface="Times New Roman MT Italics"/>
               </a:rPr>
-              <a:t>acompañamiento</a:t>
-            </a:r>
-            <a:r>
-              <a:rPr lang="en-US" sz="1723" i="1" spc="113" dirty="0">
-                <a:solidFill>
-                  <a:srgbClr val="000000"/>
-                </a:solidFill>
-                <a:latin typeface="Times New Roman MT Italics"/>
-                <a:ea typeface="Times New Roman MT Italics"/>
-                <a:cs typeface="Times New Roman MT Italics"/>
-                <a:sym typeface="Times New Roman MT Italics"/>
-              </a:rPr>
-              <a:t> de </a:t>
+              <a:t/>
+            </a:r>
+            <a:r>
+              <a:rPr lang="en-US" sz="1723" i="1" spc="113" dirty="0">
+                <a:solidFill>
+                  <a:srgbClr val="000000"/>
+                </a:solidFill>
+                <a:latin typeface="Times New Roman MT Italics"/>
+                <a:ea typeface="Times New Roman MT Italics"/>
+                <a:cs typeface="Times New Roman MT Italics"/>
+                <a:sym typeface="Times New Roman MT Italics"/>
+              </a:rPr>
+              <a:t/>
             </a:r>
             <a:r>
               <a:rPr lang="en-US" sz="1723" i="1" spc="113" dirty="0" err="1">
@@ -4058,19 +4058,19 @@
                 <a:cs typeface="Times New Roman MT Italics"/>
                 <a:sym typeface="Times New Roman MT Italics"/>
               </a:rPr>
-              <a:t>quienes</a:t>
-            </a:r>
-            <a:r>
-              <a:rPr lang="en-US" sz="1723" i="1" spc="113" dirty="0">
-                <a:solidFill>
-                  <a:srgbClr val="000000"/>
-                </a:solidFill>
-                <a:latin typeface="Times New Roman MT Italics"/>
-                <a:ea typeface="Times New Roman MT Italics"/>
-                <a:cs typeface="Times New Roman MT Italics"/>
-                <a:sym typeface="Times New Roman MT Italics"/>
-              </a:rPr>
-              <a:t>, </a:t>
+              <a:t/>
+            </a:r>
+            <a:r>
+              <a:rPr lang="en-US" sz="1723" i="1" spc="113" dirty="0">
+                <a:solidFill>
+                  <a:srgbClr val="000000"/>
+                </a:solidFill>
+                <a:latin typeface="Times New Roman MT Italics"/>
+                <a:ea typeface="Times New Roman MT Italics"/>
+                <a:cs typeface="Times New Roman MT Italics"/>
+                <a:sym typeface="Times New Roman MT Italics"/>
+              </a:rPr>
+              <a:t/>
             </a:r>
             <a:r>
               <a:rPr lang="en-US" sz="1723" i="1" spc="113" dirty="0" err="1">
@@ -4082,19 +4082,19 @@
                 <a:cs typeface="Times New Roman MT Italics"/>
                 <a:sym typeface="Times New Roman MT Italics"/>
               </a:rPr>
-              <a:t>como</a:t>
-            </a:r>
-            <a:r>
-              <a:rPr lang="en-US" sz="1723" i="1" spc="113" dirty="0">
-                <a:solidFill>
-                  <a:srgbClr val="000000"/>
-                </a:solidFill>
-                <a:latin typeface="Times New Roman MT Italics"/>
-                <a:ea typeface="Times New Roman MT Italics"/>
-                <a:cs typeface="Times New Roman MT Italics"/>
-                <a:sym typeface="Times New Roman MT Italics"/>
-              </a:rPr>
-              <a:t> </a:t>
+              <a:t/>
+            </a:r>
+            <a:r>
+              <a:rPr lang="en-US" sz="1723" i="1" spc="113" dirty="0">
+                <a:solidFill>
+                  <a:srgbClr val="000000"/>
+                </a:solidFill>
+                <a:latin typeface="Times New Roman MT Italics"/>
+                <a:ea typeface="Times New Roman MT Italics"/>
+                <a:cs typeface="Times New Roman MT Italics"/>
+                <a:sym typeface="Times New Roman MT Italics"/>
+              </a:rPr>
+              <a:t/>
             </a:r>
             <a:r>
               <a:rPr lang="en-US" sz="1723" i="1" spc="113" dirty="0" err="1">
@@ -4106,19 +4106,19 @@
                 <a:cs typeface="Times New Roman MT Italics"/>
                 <a:sym typeface="Times New Roman MT Italics"/>
               </a:rPr>
-              <a:t>usted</a:t>
-            </a:r>
-            <a:r>
-              <a:rPr lang="en-US" sz="1723" i="1" spc="113" dirty="0">
-                <a:solidFill>
-                  <a:srgbClr val="000000"/>
-                </a:solidFill>
-                <a:latin typeface="Times New Roman MT Italics"/>
-                <a:ea typeface="Times New Roman MT Italics"/>
-                <a:cs typeface="Times New Roman MT Italics"/>
-                <a:sym typeface="Times New Roman MT Italics"/>
-              </a:rPr>
-              <a:t>, </a:t>
+              <a:t/>
+            </a:r>
+            <a:r>
+              <a:rPr lang="en-US" sz="1723" i="1" spc="113" dirty="0">
+                <a:solidFill>
+                  <a:srgbClr val="000000"/>
+                </a:solidFill>
+                <a:latin typeface="Times New Roman MT Italics"/>
+                <a:ea typeface="Times New Roman MT Italics"/>
+                <a:cs typeface="Times New Roman MT Italics"/>
+                <a:sym typeface="Times New Roman MT Italics"/>
+              </a:rPr>
+              <a:t/>
             </a:r>
             <a:r>
               <a:rPr lang="en-US" sz="1723" i="1" spc="113" dirty="0" err="1">
@@ -4130,19 +4130,19 @@
                 <a:cs typeface="Times New Roman MT Italics"/>
                 <a:sym typeface="Times New Roman MT Italics"/>
               </a:rPr>
-              <a:t>honran</a:t>
-            </a:r>
-            <a:r>
-              <a:rPr lang="en-US" sz="1723" i="1" spc="113" dirty="0">
-                <a:solidFill>
-                  <a:srgbClr val="000000"/>
-                </a:solidFill>
-                <a:latin typeface="Times New Roman MT Italics"/>
-                <a:ea typeface="Times New Roman MT Italics"/>
-                <a:cs typeface="Times New Roman MT Italics"/>
-                <a:sym typeface="Times New Roman MT Italics"/>
-              </a:rPr>
-              <a:t> con </a:t>
+              <a:t/>
+            </a:r>
+            <a:r>
+              <a:rPr lang="en-US" sz="1723" i="1" spc="113" dirty="0">
+                <a:solidFill>
+                  <a:srgbClr val="000000"/>
+                </a:solidFill>
+                <a:latin typeface="Times New Roman MT Italics"/>
+                <a:ea typeface="Times New Roman MT Italics"/>
+                <a:cs typeface="Times New Roman MT Italics"/>
+                <a:sym typeface="Times New Roman MT Italics"/>
+              </a:rPr>
+              <a:t/>
             </a:r>
             <a:r>
               <a:rPr lang="en-US" sz="1723" i="1" spc="113" dirty="0" err="1">
@@ -4154,19 +4154,19 @@
                 <a:cs typeface="Times New Roman MT Italics"/>
                 <a:sym typeface="Times New Roman MT Italics"/>
               </a:rPr>
-              <a:t>su</a:t>
-            </a:r>
-            <a:r>
-              <a:rPr lang="en-US" sz="1723" i="1" spc="113" dirty="0">
-                <a:solidFill>
-                  <a:srgbClr val="000000"/>
-                </a:solidFill>
-                <a:latin typeface="Times New Roman MT Italics"/>
-                <a:ea typeface="Times New Roman MT Italics"/>
-                <a:cs typeface="Times New Roman MT Italics"/>
-                <a:sym typeface="Times New Roman MT Italics"/>
-              </a:rPr>
-              <a:t> </a:t>
+              <a:t/>
+            </a:r>
+            <a:r>
+              <a:rPr lang="en-US" sz="1723" i="1" spc="113" dirty="0">
+                <a:solidFill>
+                  <a:srgbClr val="000000"/>
+                </a:solidFill>
+                <a:latin typeface="Times New Roman MT Italics"/>
+                <a:ea typeface="Times New Roman MT Italics"/>
+                <a:cs typeface="Times New Roman MT Italics"/>
+                <a:sym typeface="Times New Roman MT Italics"/>
+              </a:rPr>
+              <a:t/>
             </a:r>
             <a:r>
               <a:rPr lang="en-US" sz="1723" i="1" spc="113" dirty="0" err="1">
@@ -4178,19 +4178,19 @@
                 <a:cs typeface="Times New Roman MT Italics"/>
                 <a:sym typeface="Times New Roman MT Italics"/>
               </a:rPr>
-              <a:t>presencia</a:t>
-            </a:r>
-            <a:r>
-              <a:rPr lang="en-US" sz="1723" i="1" spc="113" dirty="0">
-                <a:solidFill>
-                  <a:srgbClr val="000000"/>
-                </a:solidFill>
-                <a:latin typeface="Times New Roman MT Italics"/>
-                <a:ea typeface="Times New Roman MT Italics"/>
-                <a:cs typeface="Times New Roman MT Italics"/>
-                <a:sym typeface="Times New Roman MT Italics"/>
-              </a:rPr>
-              <a:t> la </a:t>
+              <a:t/>
+            </a:r>
+            <a:r>
+              <a:rPr lang="en-US" sz="1723" i="1" spc="113" dirty="0">
+                <a:solidFill>
+                  <a:srgbClr val="000000"/>
+                </a:solidFill>
+                <a:latin typeface="Times New Roman MT Italics"/>
+                <a:ea typeface="Times New Roman MT Italics"/>
+                <a:cs typeface="Times New Roman MT Italics"/>
+                <a:sym typeface="Times New Roman MT Italics"/>
+              </a:rPr>
+              <a:t/>
             </a:r>
             <a:r>
               <a:rPr lang="en-US" sz="1723" i="1" spc="113" dirty="0" err="1">
@@ -4202,19 +4202,19 @@
                 <a:cs typeface="Times New Roman MT Italics"/>
                 <a:sym typeface="Times New Roman MT Italics"/>
               </a:rPr>
-              <a:t>historia</a:t>
-            </a:r>
-            <a:r>
-              <a:rPr lang="en-US" sz="1723" i="1" spc="113" dirty="0">
-                <a:solidFill>
-                  <a:srgbClr val="000000"/>
-                </a:solidFill>
-                <a:latin typeface="Times New Roman MT Italics"/>
-                <a:ea typeface="Times New Roman MT Italics"/>
-                <a:cs typeface="Times New Roman MT Italics"/>
-                <a:sym typeface="Times New Roman MT Italics"/>
-              </a:rPr>
-              <a:t> y el </a:t>
+              <a:t/>
+            </a:r>
+            <a:r>
+              <a:rPr lang="en-US" sz="1723" i="1" spc="113" dirty="0">
+                <a:solidFill>
+                  <a:srgbClr val="000000"/>
+                </a:solidFill>
+                <a:latin typeface="Times New Roman MT Italics"/>
+                <a:ea typeface="Times New Roman MT Italics"/>
+                <a:cs typeface="Times New Roman MT Italics"/>
+                <a:sym typeface="Times New Roman MT Italics"/>
+              </a:rPr>
+              <a:t/>
             </a:r>
             <a:r>
               <a:rPr lang="en-US" sz="1723" i="1" spc="113" dirty="0" err="1">
@@ -4226,19 +4226,19 @@
                 <a:cs typeface="Times New Roman MT Italics"/>
                 <a:sym typeface="Times New Roman MT Italics"/>
               </a:rPr>
-              <a:t>espíritu</a:t>
-            </a:r>
-            <a:r>
-              <a:rPr lang="en-US" sz="1723" i="1" spc="113" dirty="0">
-                <a:solidFill>
-                  <a:srgbClr val="000000"/>
-                </a:solidFill>
-                <a:latin typeface="Times New Roman MT Italics"/>
-                <a:ea typeface="Times New Roman MT Italics"/>
-                <a:cs typeface="Times New Roman MT Italics"/>
-                <a:sym typeface="Times New Roman MT Italics"/>
-              </a:rPr>
-              <a:t> de </a:t>
+              <a:t/>
+            </a:r>
+            <a:r>
+              <a:rPr lang="en-US" sz="1723" i="1" spc="113" dirty="0">
+                <a:solidFill>
+                  <a:srgbClr val="000000"/>
+                </a:solidFill>
+                <a:latin typeface="Times New Roman MT Italics"/>
+                <a:ea typeface="Times New Roman MT Italics"/>
+                <a:cs typeface="Times New Roman MT Italics"/>
+                <a:sym typeface="Times New Roman MT Italics"/>
+              </a:rPr>
+              <a:t/>
             </a:r>
             <a:r>
               <a:rPr lang="en-US" sz="1723" i="1" spc="113" dirty="0" err="1">
@@ -4250,19 +4250,19 @@
                 <a:cs typeface="Times New Roman MT Italics"/>
                 <a:sym typeface="Times New Roman MT Italics"/>
               </a:rPr>
-              <a:t>nuestra</a:t>
-            </a:r>
-            <a:r>
-              <a:rPr lang="en-US" sz="1723" i="1" spc="113" dirty="0">
-                <a:solidFill>
-                  <a:srgbClr val="000000"/>
-                </a:solidFill>
-                <a:latin typeface="Times New Roman MT Italics"/>
-                <a:ea typeface="Times New Roman MT Italics"/>
-                <a:cs typeface="Times New Roman MT Italics"/>
-                <a:sym typeface="Times New Roman MT Italics"/>
-              </a:rPr>
-              <a:t> </a:t>
+              <a:t/>
+            </a:r>
+            <a:r>
+              <a:rPr lang="en-US" sz="1723" i="1" spc="113" dirty="0">
+                <a:solidFill>
+                  <a:srgbClr val="000000"/>
+                </a:solidFill>
+                <a:latin typeface="Times New Roman MT Italics"/>
+                <a:ea typeface="Times New Roman MT Italics"/>
+                <a:cs typeface="Times New Roman MT Italics"/>
+                <a:sym typeface="Times New Roman MT Italics"/>
+              </a:rPr>
+              <a:t/>
             </a:r>
             <a:r>
               <a:rPr lang="en-US" sz="1723" i="1" spc="113" dirty="0" err="1">
@@ -4274,19 +4274,19 @@
                 <a:cs typeface="Times New Roman MT Italics"/>
                 <a:sym typeface="Times New Roman MT Italics"/>
               </a:rPr>
-              <a:t>Arma</a:t>
-            </a:r>
-            <a:r>
-              <a:rPr lang="en-US" sz="1723" i="1" spc="113" dirty="0">
-                <a:solidFill>
-                  <a:srgbClr val="000000"/>
-                </a:solidFill>
-                <a:latin typeface="Times New Roman MT Italics"/>
-                <a:ea typeface="Times New Roman MT Italics"/>
-                <a:cs typeface="Times New Roman MT Italics"/>
-                <a:sym typeface="Times New Roman MT Italics"/>
-              </a:rPr>
-              <a:t>.</a:t>
+              <a:t/>
+            </a:r>
+            <a:r>
+              <a:rPr lang="en-US" sz="1723" i="1" spc="113" dirty="0">
+                <a:solidFill>
+                  <a:srgbClr val="000000"/>
+                </a:solidFill>
+                <a:latin typeface="Times New Roman MT Italics"/>
+                <a:ea typeface="Times New Roman MT Italics"/>
+                <a:cs typeface="Times New Roman MT Italics"/>
+                <a:sym typeface="Times New Roman MT Italics"/>
+              </a:rPr>
+              <a:t/>
             </a:r>
           </a:p>
           <a:p>

</xml_diff>